<commit_message>
Setting up Business Context
</commit_message>
<xml_diff>
--- a/Customer Retention Analysis.pptx
+++ b/Customer Retention Analysis.pptx
@@ -4,9 +4,13 @@
   <p:sldMasterIdLst>
     <p:sldMasterId id="2147483660" r:id="rId1"/>
   </p:sldMasterIdLst>
+  <p:notesMasterIdLst>
+    <p:notesMasterId r:id="rId5"/>
+  </p:notesMasterIdLst>
   <p:sldIdLst>
     <p:sldId id="256" r:id="rId2"/>
     <p:sldId id="257" r:id="rId3"/>
+    <p:sldId id="258" r:id="rId4"/>
   </p:sldIdLst>
   <p:sldSz cx="12192000" cy="6858000"/>
   <p:notesSz cx="6858000" cy="9144000"/>
@@ -106,6 +110,619 @@
     </a:lvl9pPr>
   </p:defaultTextStyle>
 </p:presentation>
+</file>
+
+<file path=ppt/revisionInfo.xml><?xml version="1.0" encoding="utf-8"?>
+<p1510:revInfo xmlns:a="http://schemas.openxmlformats.org/drawingml/2006/main" xmlns:r="http://schemas.openxmlformats.org/officeDocument/2006/relationships" xmlns:p1510="http://schemas.microsoft.com/office/powerpoint/2015/10/main">
+  <p1510:revLst>
+    <p1510:client id="{708AB096-502C-4CC0-9240-ACA9084E787F}" v="864" dt="2025-12-08T21:26:44.864"/>
+  </p1510:revLst>
+</p1510:revInfo>
+</file>
+
+<file path=ppt/changesInfos/changesInfo1.xml><?xml version="1.0" encoding="utf-8"?>
+<pc:chgInfo xmlns:a="http://schemas.openxmlformats.org/drawingml/2006/main" xmlns:r="http://schemas.openxmlformats.org/officeDocument/2006/relationships" xmlns:ac="http://schemas.microsoft.com/office/drawing/2013/main/command" xmlns:pc="http://schemas.microsoft.com/office/powerpoint/2013/main/command">
+  <pc:docChgLst>
+    <pc:chgData name="Henry Vo" userId="c18cca123e130253" providerId="LiveId" clId="{CBED1F73-AEB6-48AF-B30C-D6CFC8A51246}"/>
+    <pc:docChg chg="undo custSel addSld modSld">
+      <pc:chgData name="Henry Vo" userId="c18cca123e130253" providerId="LiveId" clId="{CBED1F73-AEB6-48AF-B30C-D6CFC8A51246}" dt="2025-12-08T21:54:05.681" v="888" actId="680"/>
+      <pc:docMkLst>
+        <pc:docMk/>
+      </pc:docMkLst>
+      <pc:sldChg chg="addSp delSp modSp mod">
+        <pc:chgData name="Henry Vo" userId="c18cca123e130253" providerId="LiveId" clId="{CBED1F73-AEB6-48AF-B30C-D6CFC8A51246}" dt="2025-12-08T21:26:44.864" v="887" actId="1076"/>
+        <pc:sldMkLst>
+          <pc:docMk/>
+          <pc:sldMk cId="2863434639" sldId="257"/>
+        </pc:sldMkLst>
+        <pc:spChg chg="mod">
+          <ac:chgData name="Henry Vo" userId="c18cca123e130253" providerId="LiveId" clId="{CBED1F73-AEB6-48AF-B30C-D6CFC8A51246}" dt="2025-12-08T20:27:21.560" v="17" actId="20577"/>
+          <ac:spMkLst>
+            <pc:docMk/>
+            <pc:sldMk cId="2863434639" sldId="257"/>
+            <ac:spMk id="2" creationId="{D9D8056B-9063-E968-A1F3-E1824812A22F}"/>
+          </ac:spMkLst>
+        </pc:spChg>
+        <pc:spChg chg="add mod">
+          <ac:chgData name="Henry Vo" userId="c18cca123e130253" providerId="LiveId" clId="{CBED1F73-AEB6-48AF-B30C-D6CFC8A51246}" dt="2025-12-08T21:26:34.628" v="886" actId="1076"/>
+          <ac:spMkLst>
+            <pc:docMk/>
+            <pc:sldMk cId="2863434639" sldId="257"/>
+            <ac:spMk id="3" creationId="{919C429F-5C2B-3714-7281-3EDE68F7C32D}"/>
+          </ac:spMkLst>
+        </pc:spChg>
+        <pc:spChg chg="del">
+          <ac:chgData name="Henry Vo" userId="c18cca123e130253" providerId="LiveId" clId="{CBED1F73-AEB6-48AF-B30C-D6CFC8A51246}" dt="2025-12-08T20:27:23.493" v="18" actId="478"/>
+          <ac:spMkLst>
+            <pc:docMk/>
+            <pc:sldMk cId="2863434639" sldId="257"/>
+            <ac:spMk id="4" creationId="{5A20D689-77A8-52F4-7325-83D949F09F0C}"/>
+          </ac:spMkLst>
+        </pc:spChg>
+        <pc:spChg chg="del">
+          <ac:chgData name="Henry Vo" userId="c18cca123e130253" providerId="LiveId" clId="{CBED1F73-AEB6-48AF-B30C-D6CFC8A51246}" dt="2025-12-08T20:27:25.376" v="21" actId="478"/>
+          <ac:spMkLst>
+            <pc:docMk/>
+            <pc:sldMk cId="2863434639" sldId="257"/>
+            <ac:spMk id="5" creationId="{19030DF6-52D1-B41F-8312-3C6939F260A5}"/>
+          </ac:spMkLst>
+        </pc:spChg>
+        <pc:spChg chg="del">
+          <ac:chgData name="Henry Vo" userId="c18cca123e130253" providerId="LiveId" clId="{CBED1F73-AEB6-48AF-B30C-D6CFC8A51246}" dt="2025-12-08T20:27:24.888" v="20" actId="478"/>
+          <ac:spMkLst>
+            <pc:docMk/>
+            <pc:sldMk cId="2863434639" sldId="257"/>
+            <ac:spMk id="6" creationId="{D2B0638C-2EBE-8C48-1D48-4103BE46E1C7}"/>
+          </ac:spMkLst>
+        </pc:spChg>
+        <pc:spChg chg="del">
+          <ac:chgData name="Henry Vo" userId="c18cca123e130253" providerId="LiveId" clId="{CBED1F73-AEB6-48AF-B30C-D6CFC8A51246}" dt="2025-12-08T20:27:24.337" v="19" actId="478"/>
+          <ac:spMkLst>
+            <pc:docMk/>
+            <pc:sldMk cId="2863434639" sldId="257"/>
+            <ac:spMk id="7" creationId="{EC1CA0F9-683D-A436-EC70-F7C63BE8A5DD}"/>
+          </ac:spMkLst>
+        </pc:spChg>
+        <pc:spChg chg="del">
+          <ac:chgData name="Henry Vo" userId="c18cca123e130253" providerId="LiveId" clId="{CBED1F73-AEB6-48AF-B30C-D6CFC8A51246}" dt="2025-12-08T20:27:26.545" v="23" actId="478"/>
+          <ac:spMkLst>
+            <pc:docMk/>
+            <pc:sldMk cId="2863434639" sldId="257"/>
+            <ac:spMk id="8" creationId="{33DCD7A4-7C7D-C0BE-1DEE-F02AA39B44CF}"/>
+          </ac:spMkLst>
+        </pc:spChg>
+        <pc:spChg chg="del">
+          <ac:chgData name="Henry Vo" userId="c18cca123e130253" providerId="LiveId" clId="{CBED1F73-AEB6-48AF-B30C-D6CFC8A51246}" dt="2025-12-08T20:27:26.089" v="22" actId="478"/>
+          <ac:spMkLst>
+            <pc:docMk/>
+            <pc:sldMk cId="2863434639" sldId="257"/>
+            <ac:spMk id="9" creationId="{EC19C215-1F45-049C-7C19-54EA642891B0}"/>
+          </ac:spMkLst>
+        </pc:spChg>
+        <pc:spChg chg="add mod">
+          <ac:chgData name="Henry Vo" userId="c18cca123e130253" providerId="LiveId" clId="{CBED1F73-AEB6-48AF-B30C-D6CFC8A51246}" dt="2025-12-08T21:26:29.962" v="885" actId="1076"/>
+          <ac:spMkLst>
+            <pc:docMk/>
+            <pc:sldMk cId="2863434639" sldId="257"/>
+            <ac:spMk id="10" creationId="{9A195A27-4EA8-1721-3F96-BF7CA2341DA2}"/>
+          </ac:spMkLst>
+        </pc:spChg>
+        <pc:spChg chg="add mod">
+          <ac:chgData name="Henry Vo" userId="c18cca123e130253" providerId="LiveId" clId="{CBED1F73-AEB6-48AF-B30C-D6CFC8A51246}" dt="2025-12-08T21:26:34.628" v="886" actId="1076"/>
+          <ac:spMkLst>
+            <pc:docMk/>
+            <pc:sldMk cId="2863434639" sldId="257"/>
+            <ac:spMk id="14" creationId="{793DB77D-16B2-FCD6-9DDB-5501DFF05DC0}"/>
+          </ac:spMkLst>
+        </pc:spChg>
+        <pc:spChg chg="add del mod">
+          <ac:chgData name="Henry Vo" userId="c18cca123e130253" providerId="LiveId" clId="{CBED1F73-AEB6-48AF-B30C-D6CFC8A51246}" dt="2025-12-08T20:58:56.586" v="73" actId="478"/>
+          <ac:spMkLst>
+            <pc:docMk/>
+            <pc:sldMk cId="2863434639" sldId="257"/>
+            <ac:spMk id="16" creationId="{F67C8F97-F509-30A0-98F1-430AFE3B8DE8}"/>
+          </ac:spMkLst>
+        </pc:spChg>
+        <pc:spChg chg="add mod">
+          <ac:chgData name="Henry Vo" userId="c18cca123e130253" providerId="LiveId" clId="{CBED1F73-AEB6-48AF-B30C-D6CFC8A51246}" dt="2025-12-08T21:26:29.962" v="885" actId="1076"/>
+          <ac:spMkLst>
+            <pc:docMk/>
+            <pc:sldMk cId="2863434639" sldId="257"/>
+            <ac:spMk id="17" creationId="{4B69FF72-BFBE-406B-E11C-5713E52016B7}"/>
+          </ac:spMkLst>
+        </pc:spChg>
+        <pc:spChg chg="add mod">
+          <ac:chgData name="Henry Vo" userId="c18cca123e130253" providerId="LiveId" clId="{CBED1F73-AEB6-48AF-B30C-D6CFC8A51246}" dt="2025-12-08T21:26:34.628" v="886" actId="1076"/>
+          <ac:spMkLst>
+            <pc:docMk/>
+            <pc:sldMk cId="2863434639" sldId="257"/>
+            <ac:spMk id="19" creationId="{2D566DE3-CE67-B22D-1EBB-5C36BDD5B411}"/>
+          </ac:spMkLst>
+        </pc:spChg>
+        <pc:spChg chg="add mod">
+          <ac:chgData name="Henry Vo" userId="c18cca123e130253" providerId="LiveId" clId="{CBED1F73-AEB6-48AF-B30C-D6CFC8A51246}" dt="2025-12-08T21:26:29.962" v="885" actId="1076"/>
+          <ac:spMkLst>
+            <pc:docMk/>
+            <pc:sldMk cId="2863434639" sldId="257"/>
+            <ac:spMk id="21" creationId="{F6FDA69B-B0E0-68A4-6E3F-543C1D2F347F}"/>
+          </ac:spMkLst>
+        </pc:spChg>
+        <pc:spChg chg="add mod">
+          <ac:chgData name="Henry Vo" userId="c18cca123e130253" providerId="LiveId" clId="{CBED1F73-AEB6-48AF-B30C-D6CFC8A51246}" dt="2025-12-08T21:26:34.628" v="886" actId="1076"/>
+          <ac:spMkLst>
+            <pc:docMk/>
+            <pc:sldMk cId="2863434639" sldId="257"/>
+            <ac:spMk id="23" creationId="{35A26B54-C9CE-78D1-33AC-1545F78EA958}"/>
+          </ac:spMkLst>
+        </pc:spChg>
+        <pc:spChg chg="add mod">
+          <ac:chgData name="Henry Vo" userId="c18cca123e130253" providerId="LiveId" clId="{CBED1F73-AEB6-48AF-B30C-D6CFC8A51246}" dt="2025-12-08T21:26:34.628" v="886" actId="1076"/>
+          <ac:spMkLst>
+            <pc:docMk/>
+            <pc:sldMk cId="2863434639" sldId="257"/>
+            <ac:spMk id="30" creationId="{CA0EE695-7346-D7BB-09AE-D0B4E0130873}"/>
+          </ac:spMkLst>
+        </pc:spChg>
+        <pc:spChg chg="add mod">
+          <ac:chgData name="Henry Vo" userId="c18cca123e130253" providerId="LiveId" clId="{CBED1F73-AEB6-48AF-B30C-D6CFC8A51246}" dt="2025-12-08T21:26:44.864" v="887" actId="1076"/>
+          <ac:spMkLst>
+            <pc:docMk/>
+            <pc:sldMk cId="2863434639" sldId="257"/>
+            <ac:spMk id="31" creationId="{DC0E58CB-8570-1F30-D90F-97EA9E5FAFB8}"/>
+          </ac:spMkLst>
+        </pc:spChg>
+        <pc:cxnChg chg="add mod">
+          <ac:chgData name="Henry Vo" userId="c18cca123e130253" providerId="LiveId" clId="{CBED1F73-AEB6-48AF-B30C-D6CFC8A51246}" dt="2025-12-08T21:26:21.572" v="884" actId="12788"/>
+          <ac:cxnSpMkLst>
+            <pc:docMk/>
+            <pc:sldMk cId="2863434639" sldId="257"/>
+            <ac:cxnSpMk id="12" creationId="{9AD999DD-5D6B-BE84-042E-B8208BB54C88}"/>
+          </ac:cxnSpMkLst>
+        </pc:cxnChg>
+      </pc:sldChg>
+      <pc:sldChg chg="new">
+        <pc:chgData name="Henry Vo" userId="c18cca123e130253" providerId="LiveId" clId="{CBED1F73-AEB6-48AF-B30C-D6CFC8A51246}" dt="2025-12-08T21:54:05.681" v="888" actId="680"/>
+        <pc:sldMkLst>
+          <pc:docMk/>
+          <pc:sldMk cId="1201758319" sldId="258"/>
+        </pc:sldMkLst>
+      </pc:sldChg>
+    </pc:docChg>
+  </pc:docChgLst>
+</pc:chgInfo>
+</file>
+
+<file path=ppt/notesMasters/notesMaster1.xml><?xml version="1.0" encoding="utf-8"?>
+<p:notesMaster xmlns:a="http://schemas.openxmlformats.org/drawingml/2006/main" xmlns:r="http://schemas.openxmlformats.org/officeDocument/2006/relationships" xmlns:p="http://schemas.openxmlformats.org/presentationml/2006/main">
+  <p:cSld>
+    <p:bg>
+      <p:bgRef idx="1001">
+        <a:schemeClr val="bg1"/>
+      </p:bgRef>
+    </p:bg>
+    <p:spTree>
+      <p:nvGrpSpPr>
+        <p:cNvPr id="1" name=""/>
+        <p:cNvGrpSpPr/>
+        <p:nvPr/>
+      </p:nvGrpSpPr>
+      <p:grpSpPr>
+        <a:xfrm>
+          <a:off x="0" y="0"/>
+          <a:ext cx="0" cy="0"/>
+          <a:chOff x="0" y="0"/>
+          <a:chExt cx="0" cy="0"/>
+        </a:xfrm>
+      </p:grpSpPr>
+      <p:sp>
+        <p:nvSpPr>
+          <p:cNvPr id="2" name="Header Placeholder 1"/>
+          <p:cNvSpPr>
+            <a:spLocks noGrp="1"/>
+          </p:cNvSpPr>
+          <p:nvPr>
+            <p:ph type="hdr" sz="quarter"/>
+          </p:nvPr>
+        </p:nvSpPr>
+        <p:spPr>
+          <a:xfrm>
+            <a:off x="0" y="0"/>
+            <a:ext cx="2971800" cy="458788"/>
+          </a:xfrm>
+          <a:prstGeom prst="rect">
+            <a:avLst/>
+          </a:prstGeom>
+        </p:spPr>
+        <p:txBody>
+          <a:bodyPr vert="horz" lIns="91440" tIns="45720" rIns="91440" bIns="45720" rtlCol="0"/>
+          <a:lstStyle>
+            <a:lvl1pPr algn="l">
+              <a:defRPr sz="1200"/>
+            </a:lvl1pPr>
+          </a:lstStyle>
+          <a:p>
+            <a:endParaRPr lang="en-US"/>
+          </a:p>
+        </p:txBody>
+      </p:sp>
+      <p:sp>
+        <p:nvSpPr>
+          <p:cNvPr id="3" name="Date Placeholder 2"/>
+          <p:cNvSpPr>
+            <a:spLocks noGrp="1"/>
+          </p:cNvSpPr>
+          <p:nvPr>
+            <p:ph type="dt" idx="1"/>
+          </p:nvPr>
+        </p:nvSpPr>
+        <p:spPr>
+          <a:xfrm>
+            <a:off x="3884613" y="0"/>
+            <a:ext cx="2971800" cy="458788"/>
+          </a:xfrm>
+          <a:prstGeom prst="rect">
+            <a:avLst/>
+          </a:prstGeom>
+        </p:spPr>
+        <p:txBody>
+          <a:bodyPr vert="horz" lIns="91440" tIns="45720" rIns="91440" bIns="45720" rtlCol="0"/>
+          <a:lstStyle>
+            <a:lvl1pPr algn="r">
+              <a:defRPr sz="1200"/>
+            </a:lvl1pPr>
+          </a:lstStyle>
+          <a:p>
+            <a:fld id="{9C049790-B49D-4D8D-B628-59414A006FDF}" type="datetimeFigureOut">
+              <a:rPr lang="en-US" smtClean="0"/>
+              <a:t>12/8/2025</a:t>
+            </a:fld>
+            <a:endParaRPr lang="en-US"/>
+          </a:p>
+        </p:txBody>
+      </p:sp>
+      <p:sp>
+        <p:nvSpPr>
+          <p:cNvPr id="4" name="Slide Image Placeholder 3"/>
+          <p:cNvSpPr>
+            <a:spLocks noGrp="1" noRot="1" noChangeAspect="1"/>
+          </p:cNvSpPr>
+          <p:nvPr>
+            <p:ph type="sldImg" idx="2"/>
+          </p:nvPr>
+        </p:nvSpPr>
+        <p:spPr>
+          <a:xfrm>
+            <a:off x="685800" y="1143000"/>
+            <a:ext cx="5486400" cy="3086100"/>
+          </a:xfrm>
+          <a:prstGeom prst="rect">
+            <a:avLst/>
+          </a:prstGeom>
+          <a:noFill/>
+          <a:ln w="12700">
+            <a:solidFill>
+              <a:prstClr val="black"/>
+            </a:solidFill>
+          </a:ln>
+        </p:spPr>
+        <p:txBody>
+          <a:bodyPr vert="horz" lIns="91440" tIns="45720" rIns="91440" bIns="45720" rtlCol="0" anchor="ctr"/>
+          <a:lstStyle/>
+          <a:p>
+            <a:endParaRPr lang="en-US"/>
+          </a:p>
+        </p:txBody>
+      </p:sp>
+      <p:sp>
+        <p:nvSpPr>
+          <p:cNvPr id="5" name="Notes Placeholder 4"/>
+          <p:cNvSpPr>
+            <a:spLocks noGrp="1"/>
+          </p:cNvSpPr>
+          <p:nvPr>
+            <p:ph type="body" sz="quarter" idx="3"/>
+          </p:nvPr>
+        </p:nvSpPr>
+        <p:spPr>
+          <a:xfrm>
+            <a:off x="685800" y="4400550"/>
+            <a:ext cx="5486400" cy="3600450"/>
+          </a:xfrm>
+          <a:prstGeom prst="rect">
+            <a:avLst/>
+          </a:prstGeom>
+        </p:spPr>
+        <p:txBody>
+          <a:bodyPr vert="horz" lIns="91440" tIns="45720" rIns="91440" bIns="45720" rtlCol="0"/>
+          <a:lstStyle/>
+          <a:p>
+            <a:pPr lvl="0"/>
+            <a:r>
+              <a:rPr lang="en-US"/>
+              <a:t>Click to edit Master text styles</a:t>
+            </a:r>
+          </a:p>
+          <a:p>
+            <a:pPr lvl="1"/>
+            <a:r>
+              <a:rPr lang="en-US"/>
+              <a:t>Second level</a:t>
+            </a:r>
+          </a:p>
+          <a:p>
+            <a:pPr lvl="2"/>
+            <a:r>
+              <a:rPr lang="en-US"/>
+              <a:t>Third level</a:t>
+            </a:r>
+          </a:p>
+          <a:p>
+            <a:pPr lvl="3"/>
+            <a:r>
+              <a:rPr lang="en-US"/>
+              <a:t>Fourth level</a:t>
+            </a:r>
+          </a:p>
+          <a:p>
+            <a:pPr lvl="4"/>
+            <a:r>
+              <a:rPr lang="en-US"/>
+              <a:t>Fifth level</a:t>
+            </a:r>
+          </a:p>
+        </p:txBody>
+      </p:sp>
+      <p:sp>
+        <p:nvSpPr>
+          <p:cNvPr id="6" name="Footer Placeholder 5"/>
+          <p:cNvSpPr>
+            <a:spLocks noGrp="1"/>
+          </p:cNvSpPr>
+          <p:nvPr>
+            <p:ph type="ftr" sz="quarter" idx="4"/>
+          </p:nvPr>
+        </p:nvSpPr>
+        <p:spPr>
+          <a:xfrm>
+            <a:off x="0" y="8685213"/>
+            <a:ext cx="2971800" cy="458787"/>
+          </a:xfrm>
+          <a:prstGeom prst="rect">
+            <a:avLst/>
+          </a:prstGeom>
+        </p:spPr>
+        <p:txBody>
+          <a:bodyPr vert="horz" lIns="91440" tIns="45720" rIns="91440" bIns="45720" rtlCol="0" anchor="b"/>
+          <a:lstStyle>
+            <a:lvl1pPr algn="l">
+              <a:defRPr sz="1200"/>
+            </a:lvl1pPr>
+          </a:lstStyle>
+          <a:p>
+            <a:endParaRPr lang="en-US"/>
+          </a:p>
+        </p:txBody>
+      </p:sp>
+      <p:sp>
+        <p:nvSpPr>
+          <p:cNvPr id="7" name="Slide Number Placeholder 6"/>
+          <p:cNvSpPr>
+            <a:spLocks noGrp="1"/>
+          </p:cNvSpPr>
+          <p:nvPr>
+            <p:ph type="sldNum" sz="quarter" idx="5"/>
+          </p:nvPr>
+        </p:nvSpPr>
+        <p:spPr>
+          <a:xfrm>
+            <a:off x="3884613" y="8685213"/>
+            <a:ext cx="2971800" cy="458787"/>
+          </a:xfrm>
+          <a:prstGeom prst="rect">
+            <a:avLst/>
+          </a:prstGeom>
+        </p:spPr>
+        <p:txBody>
+          <a:bodyPr vert="horz" lIns="91440" tIns="45720" rIns="91440" bIns="45720" rtlCol="0" anchor="b"/>
+          <a:lstStyle>
+            <a:lvl1pPr algn="r">
+              <a:defRPr sz="1200"/>
+            </a:lvl1pPr>
+          </a:lstStyle>
+          <a:p>
+            <a:fld id="{1F6B6D16-8807-4B47-A511-DB6453DC6DDE}" type="slidenum">
+              <a:rPr lang="en-US" smtClean="0"/>
+              <a:t>‹#›</a:t>
+            </a:fld>
+            <a:endParaRPr lang="en-US"/>
+          </a:p>
+        </p:txBody>
+      </p:sp>
+    </p:spTree>
+    <p:extLst>
+      <p:ext uri="{BB962C8B-B14F-4D97-AF65-F5344CB8AC3E}">
+        <p14:creationId xmlns:p14="http://schemas.microsoft.com/office/powerpoint/2010/main" val="1463389292"/>
+      </p:ext>
+    </p:extLst>
+  </p:cSld>
+  <p:clrMap bg1="lt1" tx1="dk1" bg2="lt2" tx2="dk2" accent1="accent1" accent2="accent2" accent3="accent3" accent4="accent4" accent5="accent5" accent6="accent6" hlink="hlink" folHlink="folHlink"/>
+  <p:notesStyle>
+    <a:lvl1pPr marL="0" algn="l" defTabSz="914400" rtl="0" eaLnBrk="1" latinLnBrk="0" hangingPunct="1">
+      <a:defRPr sz="1200" kern="1200">
+        <a:solidFill>
+          <a:schemeClr val="tx1"/>
+        </a:solidFill>
+        <a:latin typeface="+mn-lt"/>
+        <a:ea typeface="+mn-ea"/>
+        <a:cs typeface="+mn-cs"/>
+      </a:defRPr>
+    </a:lvl1pPr>
+    <a:lvl2pPr marL="457200" algn="l" defTabSz="914400" rtl="0" eaLnBrk="1" latinLnBrk="0" hangingPunct="1">
+      <a:defRPr sz="1200" kern="1200">
+        <a:solidFill>
+          <a:schemeClr val="tx1"/>
+        </a:solidFill>
+        <a:latin typeface="+mn-lt"/>
+        <a:ea typeface="+mn-ea"/>
+        <a:cs typeface="+mn-cs"/>
+      </a:defRPr>
+    </a:lvl2pPr>
+    <a:lvl3pPr marL="914400" algn="l" defTabSz="914400" rtl="0" eaLnBrk="1" latinLnBrk="0" hangingPunct="1">
+      <a:defRPr sz="1200" kern="1200">
+        <a:solidFill>
+          <a:schemeClr val="tx1"/>
+        </a:solidFill>
+        <a:latin typeface="+mn-lt"/>
+        <a:ea typeface="+mn-ea"/>
+        <a:cs typeface="+mn-cs"/>
+      </a:defRPr>
+    </a:lvl3pPr>
+    <a:lvl4pPr marL="1371600" algn="l" defTabSz="914400" rtl="0" eaLnBrk="1" latinLnBrk="0" hangingPunct="1">
+      <a:defRPr sz="1200" kern="1200">
+        <a:solidFill>
+          <a:schemeClr val="tx1"/>
+        </a:solidFill>
+        <a:latin typeface="+mn-lt"/>
+        <a:ea typeface="+mn-ea"/>
+        <a:cs typeface="+mn-cs"/>
+      </a:defRPr>
+    </a:lvl4pPr>
+    <a:lvl5pPr marL="1828800" algn="l" defTabSz="914400" rtl="0" eaLnBrk="1" latinLnBrk="0" hangingPunct="1">
+      <a:defRPr sz="1200" kern="1200">
+        <a:solidFill>
+          <a:schemeClr val="tx1"/>
+        </a:solidFill>
+        <a:latin typeface="+mn-lt"/>
+        <a:ea typeface="+mn-ea"/>
+        <a:cs typeface="+mn-cs"/>
+      </a:defRPr>
+    </a:lvl5pPr>
+    <a:lvl6pPr marL="2286000" algn="l" defTabSz="914400" rtl="0" eaLnBrk="1" latinLnBrk="0" hangingPunct="1">
+      <a:defRPr sz="1200" kern="1200">
+        <a:solidFill>
+          <a:schemeClr val="tx1"/>
+        </a:solidFill>
+        <a:latin typeface="+mn-lt"/>
+        <a:ea typeface="+mn-ea"/>
+        <a:cs typeface="+mn-cs"/>
+      </a:defRPr>
+    </a:lvl6pPr>
+    <a:lvl7pPr marL="2743200" algn="l" defTabSz="914400" rtl="0" eaLnBrk="1" latinLnBrk="0" hangingPunct="1">
+      <a:defRPr sz="1200" kern="1200">
+        <a:solidFill>
+          <a:schemeClr val="tx1"/>
+        </a:solidFill>
+        <a:latin typeface="+mn-lt"/>
+        <a:ea typeface="+mn-ea"/>
+        <a:cs typeface="+mn-cs"/>
+      </a:defRPr>
+    </a:lvl7pPr>
+    <a:lvl8pPr marL="3200400" algn="l" defTabSz="914400" rtl="0" eaLnBrk="1" latinLnBrk="0" hangingPunct="1">
+      <a:defRPr sz="1200" kern="1200">
+        <a:solidFill>
+          <a:schemeClr val="tx1"/>
+        </a:solidFill>
+        <a:latin typeface="+mn-lt"/>
+        <a:ea typeface="+mn-ea"/>
+        <a:cs typeface="+mn-cs"/>
+      </a:defRPr>
+    </a:lvl8pPr>
+    <a:lvl9pPr marL="3657600" algn="l" defTabSz="914400" rtl="0" eaLnBrk="1" latinLnBrk="0" hangingPunct="1">
+      <a:defRPr sz="1200" kern="1200">
+        <a:solidFill>
+          <a:schemeClr val="tx1"/>
+        </a:solidFill>
+        <a:latin typeface="+mn-lt"/>
+        <a:ea typeface="+mn-ea"/>
+        <a:cs typeface="+mn-cs"/>
+      </a:defRPr>
+    </a:lvl9pPr>
+  </p:notesStyle>
+</p:notesMaster>
+</file>
+
+<file path=ppt/notesSlides/notesSlide1.xml><?xml version="1.0" encoding="utf-8"?>
+<p:notes xmlns:a="http://schemas.openxmlformats.org/drawingml/2006/main" xmlns:r="http://schemas.openxmlformats.org/officeDocument/2006/relationships" xmlns:p="http://schemas.openxmlformats.org/presentationml/2006/main">
+  <p:cSld>
+    <p:spTree>
+      <p:nvGrpSpPr>
+        <p:cNvPr id="1" name=""/>
+        <p:cNvGrpSpPr/>
+        <p:nvPr/>
+      </p:nvGrpSpPr>
+      <p:grpSpPr>
+        <a:xfrm>
+          <a:off x="0" y="0"/>
+          <a:ext cx="0" cy="0"/>
+          <a:chOff x="0" y="0"/>
+          <a:chExt cx="0" cy="0"/>
+        </a:xfrm>
+      </p:grpSpPr>
+      <p:sp>
+        <p:nvSpPr>
+          <p:cNvPr id="2" name="Slide Image Placeholder 1"/>
+          <p:cNvSpPr>
+            <a:spLocks noGrp="1" noRot="1" noChangeAspect="1"/>
+          </p:cNvSpPr>
+          <p:nvPr>
+            <p:ph type="sldImg"/>
+          </p:nvPr>
+        </p:nvSpPr>
+        <p:spPr/>
+      </p:sp>
+      <p:sp>
+        <p:nvSpPr>
+          <p:cNvPr id="3" name="Notes Placeholder 2"/>
+          <p:cNvSpPr>
+            <a:spLocks noGrp="1"/>
+          </p:cNvSpPr>
+          <p:nvPr>
+            <p:ph type="body" idx="1"/>
+          </p:nvPr>
+        </p:nvSpPr>
+        <p:spPr/>
+        <p:txBody>
+          <a:bodyPr/>
+          <a:lstStyle/>
+          <a:p>
+            <a:endParaRPr lang="en-US"/>
+          </a:p>
+        </p:txBody>
+      </p:sp>
+      <p:sp>
+        <p:nvSpPr>
+          <p:cNvPr id="4" name="Slide Number Placeholder 3"/>
+          <p:cNvSpPr>
+            <a:spLocks noGrp="1"/>
+          </p:cNvSpPr>
+          <p:nvPr>
+            <p:ph type="sldNum" sz="quarter" idx="5"/>
+          </p:nvPr>
+        </p:nvSpPr>
+        <p:spPr/>
+        <p:txBody>
+          <a:bodyPr/>
+          <a:lstStyle/>
+          <a:p>
+            <a:fld id="{1F6B6D16-8807-4B47-A511-DB6453DC6DDE}" type="slidenum">
+              <a:rPr lang="en-US" smtClean="0"/>
+              <a:t>2</a:t>
+            </a:fld>
+            <a:endParaRPr lang="en-US"/>
+          </a:p>
+        </p:txBody>
+      </p:sp>
+    </p:spTree>
+    <p:extLst>
+      <p:ext uri="{BB962C8B-B14F-4D97-AF65-F5344CB8AC3E}">
+        <p14:creationId xmlns:p14="http://schemas.microsoft.com/office/powerpoint/2010/main" val="1217006089"/>
+      </p:ext>
+    </p:extLst>
+  </p:cSld>
+  <p:clrMapOvr>
+    <a:masterClrMapping/>
+  </p:clrMapOvr>
+</p:notes>
 </file>
 
 <file path=ppt/slideLayouts/slideLayout1.xml><?xml version="1.0" encoding="utf-8"?>
@@ -275,6 +892,13 @@
               <a:schemeClr val="lt1"/>
             </a:fontRef>
           </p:style>
+          <p:txBody>
+            <a:bodyPr/>
+            <a:lstStyle/>
+            <a:p>
+              <a:endParaRPr lang="en-US"/>
+            </a:p>
+          </p:txBody>
         </p:sp>
         <p:sp>
           <p:nvSpPr>
@@ -338,6 +962,13 @@
               <a:schemeClr val="lt1"/>
             </a:fontRef>
           </p:style>
+          <p:txBody>
+            <a:bodyPr/>
+            <a:lstStyle/>
+            <a:p>
+              <a:endParaRPr lang="en-US"/>
+            </a:p>
+          </p:txBody>
         </p:sp>
         <p:sp>
           <p:nvSpPr>
@@ -379,6 +1010,13 @@
               <a:schemeClr val="lt1"/>
             </a:fontRef>
           </p:style>
+          <p:txBody>
+            <a:bodyPr/>
+            <a:lstStyle/>
+            <a:p>
+              <a:endParaRPr lang="en-US"/>
+            </a:p>
+          </p:txBody>
         </p:sp>
         <p:sp>
           <p:nvSpPr>
@@ -443,6 +1081,13 @@
               <a:schemeClr val="lt1"/>
             </a:fontRef>
           </p:style>
+          <p:txBody>
+            <a:bodyPr/>
+            <a:lstStyle/>
+            <a:p>
+              <a:endParaRPr lang="en-US"/>
+            </a:p>
+          </p:txBody>
         </p:sp>
         <p:sp>
           <p:nvSpPr>
@@ -508,6 +1153,13 @@
               <a:schemeClr val="lt1"/>
             </a:fontRef>
           </p:style>
+          <p:txBody>
+            <a:bodyPr/>
+            <a:lstStyle/>
+            <a:p>
+              <a:endParaRPr lang="en-US"/>
+            </a:p>
+          </p:txBody>
         </p:sp>
         <p:sp>
           <p:nvSpPr>
@@ -571,6 +1223,13 @@
               <a:schemeClr val="lt1"/>
             </a:fontRef>
           </p:style>
+          <p:txBody>
+            <a:bodyPr/>
+            <a:lstStyle/>
+            <a:p>
+              <a:endParaRPr lang="en-US"/>
+            </a:p>
+          </p:txBody>
         </p:sp>
         <p:sp>
           <p:nvSpPr>
@@ -612,6 +1271,13 @@
               <a:schemeClr val="lt1"/>
             </a:fontRef>
           </p:style>
+          <p:txBody>
+            <a:bodyPr/>
+            <a:lstStyle/>
+            <a:p>
+              <a:endParaRPr lang="en-US"/>
+            </a:p>
+          </p:txBody>
         </p:sp>
         <p:sp>
           <p:nvSpPr>
@@ -653,6 +1319,13 @@
               <a:schemeClr val="lt1"/>
             </a:fontRef>
           </p:style>
+          <p:txBody>
+            <a:bodyPr/>
+            <a:lstStyle/>
+            <a:p>
+              <a:endParaRPr lang="en-US"/>
+            </a:p>
+          </p:txBody>
         </p:sp>
       </p:grpSp>
       <p:sp>
@@ -689,7 +1362,6 @@
               <a:rPr lang="en-US"/>
               <a:t>Click to edit Master title style</a:t>
             </a:r>
-            <a:endParaRPr lang="en-US" dirty="0"/>
           </a:p>
         </p:txBody>
       </p:sp>
@@ -809,7 +1481,6 @@
               <a:rPr lang="en-US"/>
               <a:t>Click to edit Master subtitle style</a:t>
             </a:r>
-            <a:endParaRPr lang="en-US" dirty="0"/>
           </a:p>
         </p:txBody>
       </p:sp>
@@ -830,7 +1501,7 @@
           <a:p>
             <a:fld id="{74411A3F-4DB3-47ED-809A-CD27B21BFB64}" type="datetimeFigureOut">
               <a:rPr lang="en-US" smtClean="0"/>
-              <a:t>11/25/2025</a:t>
+              <a:t>12/8/2025</a:t>
             </a:fld>
             <a:endParaRPr lang="en-US"/>
           </a:p>
@@ -938,7 +1609,6 @@
               <a:rPr lang="en-US"/>
               <a:t>Click to edit Master title style</a:t>
             </a:r>
-            <a:endParaRPr lang="en-US" dirty="0"/>
           </a:p>
         </p:txBody>
       </p:sp>
@@ -1081,7 +1751,7 @@
           <a:p>
             <a:fld id="{74411A3F-4DB3-47ED-809A-CD27B21BFB64}" type="datetimeFigureOut">
               <a:rPr lang="en-US" smtClean="0"/>
-              <a:t>11/25/2025</a:t>
+              <a:t>12/8/2025</a:t>
             </a:fld>
             <a:endParaRPr lang="en-US"/>
           </a:p>
@@ -1189,7 +1859,6 @@
               <a:rPr lang="en-US"/>
               <a:t>Click to edit Master title style</a:t>
             </a:r>
-            <a:endParaRPr lang="en-US" dirty="0"/>
           </a:p>
         </p:txBody>
       </p:sp>
@@ -1395,7 +2064,7 @@
           <a:p>
             <a:fld id="{74411A3F-4DB3-47ED-809A-CD27B21BFB64}" type="datetimeFigureOut">
               <a:rPr lang="en-US" smtClean="0"/>
-              <a:t>11/25/2025</a:t>
+              <a:t>12/8/2025</a:t>
             </a:fld>
             <a:endParaRPr lang="en-US"/>
           </a:p>
@@ -1466,7 +2135,7 @@
           <a:p>
             <a:pPr lvl="0"/>
             <a:r>
-              <a:rPr lang="en-US" sz="8000" baseline="0" dirty="0">
+              <a:rPr lang="en-US" sz="8000" baseline="0">
                 <a:ln w="3175" cmpd="sng">
                   <a:noFill/>
                 </a:ln>
@@ -1507,7 +2176,7 @@
           <a:p>
             <a:pPr lvl="0"/>
             <a:r>
-              <a:rPr lang="en-US" sz="8000" baseline="0" dirty="0">
+              <a:rPr lang="en-US" sz="8000" baseline="0">
                 <a:ln w="3175" cmpd="sng">
                   <a:noFill/>
                 </a:ln>
@@ -1521,7 +2190,7 @@
               </a:rPr>
               <a:t>”</a:t>
             </a:r>
-            <a:endParaRPr lang="en-US" dirty="0">
+            <a:endParaRPr lang="en-US">
               <a:solidFill>
                 <a:schemeClr val="accent1">
                   <a:lumMod val="60000"/>
@@ -1593,7 +2262,6 @@
               <a:rPr lang="en-US"/>
               <a:t>Click to edit Master title style</a:t>
             </a:r>
-            <a:endParaRPr lang="en-US" dirty="0"/>
           </a:p>
         </p:txBody>
       </p:sp>
@@ -1736,7 +2404,7 @@
           <a:p>
             <a:fld id="{74411A3F-4DB3-47ED-809A-CD27B21BFB64}" type="datetimeFigureOut">
               <a:rPr lang="en-US" smtClean="0"/>
-              <a:t>11/25/2025</a:t>
+              <a:t>12/8/2025</a:t>
             </a:fld>
             <a:endParaRPr lang="en-US"/>
           </a:p>
@@ -1844,7 +2512,6 @@
               <a:rPr lang="en-US"/>
               <a:t>Click to edit Master title style</a:t>
             </a:r>
-            <a:endParaRPr lang="en-US" dirty="0"/>
           </a:p>
         </p:txBody>
       </p:sp>
@@ -2050,7 +2717,7 @@
           <a:p>
             <a:fld id="{74411A3F-4DB3-47ED-809A-CD27B21BFB64}" type="datetimeFigureOut">
               <a:rPr lang="en-US" smtClean="0"/>
-              <a:t>11/25/2025</a:t>
+              <a:t>12/8/2025</a:t>
             </a:fld>
             <a:endParaRPr lang="en-US"/>
           </a:p>
@@ -2121,7 +2788,7 @@
           <a:p>
             <a:pPr lvl="0"/>
             <a:r>
-              <a:rPr lang="en-US" sz="8000" baseline="0" dirty="0">
+              <a:rPr lang="en-US" sz="8000" baseline="0">
                 <a:ln w="3175" cmpd="sng">
                   <a:noFill/>
                 </a:ln>
@@ -2162,7 +2829,7 @@
           <a:p>
             <a:pPr lvl="0"/>
             <a:r>
-              <a:rPr lang="en-US" sz="8000" baseline="0" dirty="0">
+              <a:rPr lang="en-US" sz="8000" baseline="0">
                 <a:ln w="3175" cmpd="sng">
                   <a:noFill/>
                 </a:ln>
@@ -2240,7 +2907,6 @@
               <a:rPr lang="en-US"/>
               <a:t>Click to edit Master title style</a:t>
             </a:r>
-            <a:endParaRPr lang="en-US" dirty="0"/>
           </a:p>
         </p:txBody>
       </p:sp>
@@ -2443,7 +3109,7 @@
           <a:p>
             <a:fld id="{74411A3F-4DB3-47ED-809A-CD27B21BFB64}" type="datetimeFigureOut">
               <a:rPr lang="en-US" smtClean="0"/>
-              <a:t>11/25/2025</a:t>
+              <a:t>12/8/2025</a:t>
             </a:fld>
             <a:endParaRPr lang="en-US"/>
           </a:p>
@@ -2540,7 +3206,6 @@
               <a:rPr lang="en-US"/>
               <a:t>Click to edit Master title style</a:t>
             </a:r>
-            <a:endParaRPr lang="en-US" dirty="0"/>
           </a:p>
         </p:txBody>
       </p:sp>
@@ -2592,7 +3257,6 @@
               <a:rPr lang="en-US"/>
               <a:t>Fifth level</a:t>
             </a:r>
-            <a:endParaRPr lang="en-US" dirty="0"/>
           </a:p>
         </p:txBody>
       </p:sp>
@@ -2613,7 +3277,7 @@
           <a:p>
             <a:fld id="{74411A3F-4DB3-47ED-809A-CD27B21BFB64}" type="datetimeFigureOut">
               <a:rPr lang="en-US" smtClean="0"/>
-              <a:t>11/25/2025</a:t>
+              <a:t>12/8/2025</a:t>
             </a:fld>
             <a:endParaRPr lang="en-US"/>
           </a:p>
@@ -2715,7 +3379,6 @@
               <a:rPr lang="en-US"/>
               <a:t>Click to edit Master title style</a:t>
             </a:r>
-            <a:endParaRPr lang="en-US" dirty="0"/>
           </a:p>
         </p:txBody>
       </p:sp>
@@ -2772,7 +3435,6 @@
               <a:rPr lang="en-US"/>
               <a:t>Fifth level</a:t>
             </a:r>
-            <a:endParaRPr lang="en-US" dirty="0"/>
           </a:p>
         </p:txBody>
       </p:sp>
@@ -2793,7 +3455,7 @@
           <a:p>
             <a:fld id="{74411A3F-4DB3-47ED-809A-CD27B21BFB64}" type="datetimeFigureOut">
               <a:rPr lang="en-US" smtClean="0"/>
-              <a:t>11/25/2025</a:t>
+              <a:t>12/8/2025</a:t>
             </a:fld>
             <a:endParaRPr lang="en-US"/>
           </a:p>
@@ -2896,7 +3558,6 @@
               <a:rPr lang="en-US"/>
               <a:t>Click to edit Master title style</a:t>
             </a:r>
-            <a:endParaRPr lang="en-US" dirty="0"/>
           </a:p>
         </p:txBody>
       </p:sp>
@@ -2948,7 +3609,6 @@
               <a:rPr lang="en-US"/>
               <a:t>Fifth level</a:t>
             </a:r>
-            <a:endParaRPr lang="en-US" dirty="0"/>
           </a:p>
         </p:txBody>
       </p:sp>
@@ -2969,7 +3629,7 @@
           <a:p>
             <a:fld id="{74411A3F-4DB3-47ED-809A-CD27B21BFB64}" type="datetimeFigureOut">
               <a:rPr lang="en-US" smtClean="0"/>
-              <a:t>11/25/2025</a:t>
+              <a:t>12/8/2025</a:t>
             </a:fld>
             <a:endParaRPr lang="en-US"/>
           </a:p>
@@ -3075,7 +3735,6 @@
               <a:rPr lang="en-US"/>
               <a:t>Click to edit Master title style</a:t>
             </a:r>
-            <a:endParaRPr lang="en-US" dirty="0"/>
           </a:p>
         </p:txBody>
       </p:sp>
@@ -3216,7 +3875,7 @@
           <a:p>
             <a:fld id="{74411A3F-4DB3-47ED-809A-CD27B21BFB64}" type="datetimeFigureOut">
               <a:rPr lang="en-US" smtClean="0"/>
-              <a:t>11/25/2025</a:t>
+              <a:t>12/8/2025</a:t>
             </a:fld>
             <a:endParaRPr lang="en-US"/>
           </a:p>
@@ -3313,7 +3972,6 @@
               <a:rPr lang="en-US"/>
               <a:t>Click to edit Master title style</a:t>
             </a:r>
-            <a:endParaRPr lang="en-US" dirty="0"/>
           </a:p>
         </p:txBody>
       </p:sp>
@@ -3370,7 +4028,6 @@
               <a:rPr lang="en-US"/>
               <a:t>Fifth level</a:t>
             </a:r>
-            <a:endParaRPr lang="en-US" dirty="0"/>
           </a:p>
         </p:txBody>
       </p:sp>
@@ -3427,7 +4084,6 @@
               <a:rPr lang="en-US"/>
               <a:t>Fifth level</a:t>
             </a:r>
-            <a:endParaRPr lang="en-US" dirty="0"/>
           </a:p>
         </p:txBody>
       </p:sp>
@@ -3448,7 +4104,7 @@
           <a:p>
             <a:fld id="{74411A3F-4DB3-47ED-809A-CD27B21BFB64}" type="datetimeFigureOut">
               <a:rPr lang="en-US" smtClean="0"/>
-              <a:t>11/25/2025</a:t>
+              <a:t>12/8/2025</a:t>
             </a:fld>
             <a:endParaRPr lang="en-US"/>
           </a:p>
@@ -3549,7 +4205,6 @@
               <a:rPr lang="en-US"/>
               <a:t>Click to edit Master title style</a:t>
             </a:r>
-            <a:endParaRPr lang="en-US" dirty="0"/>
           </a:p>
         </p:txBody>
       </p:sp>
@@ -3675,7 +4330,6 @@
               <a:rPr lang="en-US"/>
               <a:t>Fifth level</a:t>
             </a:r>
-            <a:endParaRPr lang="en-US" dirty="0"/>
           </a:p>
         </p:txBody>
       </p:sp>
@@ -3801,7 +4455,6 @@
               <a:rPr lang="en-US"/>
               <a:t>Fifth level</a:t>
             </a:r>
-            <a:endParaRPr lang="en-US" dirty="0"/>
           </a:p>
         </p:txBody>
       </p:sp>
@@ -3822,7 +4475,7 @@
           <a:p>
             <a:fld id="{74411A3F-4DB3-47ED-809A-CD27B21BFB64}" type="datetimeFigureOut">
               <a:rPr lang="en-US" smtClean="0"/>
-              <a:t>11/25/2025</a:t>
+              <a:t>12/8/2025</a:t>
             </a:fld>
             <a:endParaRPr lang="en-US"/>
           </a:p>
@@ -3924,7 +4577,6 @@
               <a:rPr lang="en-US"/>
               <a:t>Click to edit Master title style</a:t>
             </a:r>
-            <a:endParaRPr lang="en-US" dirty="0"/>
           </a:p>
         </p:txBody>
       </p:sp>
@@ -3945,7 +4597,7 @@
           <a:p>
             <a:fld id="{74411A3F-4DB3-47ED-809A-CD27B21BFB64}" type="datetimeFigureOut">
               <a:rPr lang="en-US" smtClean="0"/>
-              <a:t>11/25/2025</a:t>
+              <a:t>12/8/2025</a:t>
             </a:fld>
             <a:endParaRPr lang="en-US"/>
           </a:p>
@@ -4040,7 +4692,7 @@
           <a:p>
             <a:fld id="{74411A3F-4DB3-47ED-809A-CD27B21BFB64}" type="datetimeFigureOut">
               <a:rPr lang="en-US" smtClean="0"/>
-              <a:t>11/25/2025</a:t>
+              <a:t>12/8/2025</a:t>
             </a:fld>
             <a:endParaRPr lang="en-US"/>
           </a:p>
@@ -4148,7 +4800,6 @@
               <a:rPr lang="en-US"/>
               <a:t>Click to edit Master title style</a:t>
             </a:r>
-            <a:endParaRPr lang="en-US" dirty="0"/>
           </a:p>
         </p:txBody>
       </p:sp>
@@ -4207,7 +4858,6 @@
               <a:rPr lang="en-US"/>
               <a:t>Fifth level</a:t>
             </a:r>
-            <a:endParaRPr lang="en-US" dirty="0"/>
           </a:p>
         </p:txBody>
       </p:sp>
@@ -4295,7 +4945,7 @@
           <a:p>
             <a:fld id="{74411A3F-4DB3-47ED-809A-CD27B21BFB64}" type="datetimeFigureOut">
               <a:rPr lang="en-US" smtClean="0"/>
-              <a:t>11/25/2025</a:t>
+              <a:t>12/8/2025</a:t>
             </a:fld>
             <a:endParaRPr lang="en-US"/>
           </a:p>
@@ -4403,7 +5053,6 @@
               <a:rPr lang="en-US"/>
               <a:t>Click to edit Master title style</a:t>
             </a:r>
-            <a:endParaRPr lang="en-US" dirty="0"/>
           </a:p>
         </p:txBody>
       </p:sp>
@@ -4470,7 +5119,6 @@
               <a:rPr lang="en-US"/>
               <a:t>Click icon to add picture</a:t>
             </a:r>
-            <a:endParaRPr lang="en-US" dirty="0"/>
           </a:p>
         </p:txBody>
       </p:sp>
@@ -4558,7 +5206,7 @@
           <a:p>
             <a:fld id="{74411A3F-4DB3-47ED-809A-CD27B21BFB64}" type="datetimeFigureOut">
               <a:rPr lang="en-US" smtClean="0"/>
-              <a:t>11/25/2025</a:t>
+              <a:t>12/8/2025</a:t>
             </a:fld>
             <a:endParaRPr lang="en-US"/>
           </a:p>
@@ -4791,6 +5439,13 @@
               <a:schemeClr val="lt1"/>
             </a:fontRef>
           </p:style>
+          <p:txBody>
+            <a:bodyPr/>
+            <a:lstStyle/>
+            <a:p>
+              <a:endParaRPr lang="en-US"/>
+            </a:p>
+          </p:txBody>
         </p:sp>
         <p:sp>
           <p:nvSpPr>
@@ -4854,6 +5509,13 @@
               <a:schemeClr val="lt1"/>
             </a:fontRef>
           </p:style>
+          <p:txBody>
+            <a:bodyPr/>
+            <a:lstStyle/>
+            <a:p>
+              <a:endParaRPr lang="en-US"/>
+            </a:p>
+          </p:txBody>
         </p:sp>
         <p:sp>
           <p:nvSpPr>
@@ -4895,6 +5557,13 @@
               <a:schemeClr val="lt1"/>
             </a:fontRef>
           </p:style>
+          <p:txBody>
+            <a:bodyPr/>
+            <a:lstStyle/>
+            <a:p>
+              <a:endParaRPr lang="en-US"/>
+            </a:p>
+          </p:txBody>
         </p:sp>
         <p:sp>
           <p:nvSpPr>
@@ -4959,6 +5628,13 @@
               <a:schemeClr val="lt1"/>
             </a:fontRef>
           </p:style>
+          <p:txBody>
+            <a:bodyPr/>
+            <a:lstStyle/>
+            <a:p>
+              <a:endParaRPr lang="en-US"/>
+            </a:p>
+          </p:txBody>
         </p:sp>
         <p:sp>
           <p:nvSpPr>
@@ -5024,6 +5700,13 @@
               <a:schemeClr val="lt1"/>
             </a:fontRef>
           </p:style>
+          <p:txBody>
+            <a:bodyPr/>
+            <a:lstStyle/>
+            <a:p>
+              <a:endParaRPr lang="en-US"/>
+            </a:p>
+          </p:txBody>
         </p:sp>
         <p:sp>
           <p:nvSpPr>
@@ -5087,6 +5770,13 @@
               <a:schemeClr val="lt1"/>
             </a:fontRef>
           </p:style>
+          <p:txBody>
+            <a:bodyPr/>
+            <a:lstStyle/>
+            <a:p>
+              <a:endParaRPr lang="en-US"/>
+            </a:p>
+          </p:txBody>
         </p:sp>
         <p:sp>
           <p:nvSpPr>
@@ -5128,6 +5818,13 @@
               <a:schemeClr val="lt1"/>
             </a:fontRef>
           </p:style>
+          <p:txBody>
+            <a:bodyPr/>
+            <a:lstStyle/>
+            <a:p>
+              <a:endParaRPr lang="en-US"/>
+            </a:p>
+          </p:txBody>
         </p:sp>
         <p:sp>
           <p:nvSpPr>
@@ -5169,6 +5866,13 @@
               <a:schemeClr val="lt1"/>
             </a:fontRef>
           </p:style>
+          <p:txBody>
+            <a:bodyPr/>
+            <a:lstStyle/>
+            <a:p>
+              <a:endParaRPr lang="en-US"/>
+            </a:p>
+          </p:txBody>
         </p:sp>
       </p:grpSp>
       <p:sp>
@@ -5200,7 +5904,6 @@
               <a:rPr lang="en-US"/>
               <a:t>Click to edit Master title style</a:t>
             </a:r>
-            <a:endParaRPr lang="en-US" dirty="0"/>
           </a:p>
         </p:txBody>
       </p:sp>
@@ -5262,7 +5965,6 @@
               <a:rPr lang="en-US"/>
               <a:t>Fifth level</a:t>
             </a:r>
-            <a:endParaRPr lang="en-US" dirty="0"/>
           </a:p>
         </p:txBody>
       </p:sp>
@@ -5301,7 +6003,7 @@
           <a:p>
             <a:fld id="{74411A3F-4DB3-47ED-809A-CD27B21BFB64}" type="datetimeFigureOut">
               <a:rPr lang="en-US" smtClean="0"/>
-              <a:t>11/25/2025</a:t>
+              <a:t>12/8/2025</a:t>
             </a:fld>
             <a:endParaRPr lang="en-US"/>
           </a:p>
@@ -5853,7 +6555,7 @@
           <a:p>
             <a:pPr algn="ctr"/>
             <a:r>
-              <a:rPr lang="en-US" dirty="0"/>
+              <a:rPr lang="en-US"/>
               <a:t>Customer Retention Analysis</a:t>
             </a:r>
           </a:p>
@@ -5918,18 +6620,18 @@
           <a:lstStyle/>
           <a:p>
             <a:r>
-              <a:rPr lang="en-US" dirty="0"/>
-              <a:t>Customer Overview</a:t>
-            </a:r>
-          </a:p>
-        </p:txBody>
-      </p:sp>
-      <p:sp>
-        <p:nvSpPr>
-          <p:cNvPr id="4" name="TextBox 3">
+              <a:rPr lang="en-US"/>
+              <a:t>Business Context</a:t>
+            </a:r>
+          </a:p>
+        </p:txBody>
+      </p:sp>
+      <p:sp>
+        <p:nvSpPr>
+          <p:cNvPr id="3" name="TextBox 2">
             <a:extLst>
               <a:ext uri="{FF2B5EF4-FFF2-40B4-BE49-F238E27FC236}">
-                <a16:creationId xmlns:a16="http://schemas.microsoft.com/office/drawing/2014/main" id="{5A20D689-77A8-52F4-7325-83D949F09F0C}"/>
+                <a16:creationId xmlns:a16="http://schemas.microsoft.com/office/drawing/2014/main" id="{919C429F-5C2B-3714-7281-3EDE68F7C32D}"/>
               </a:ext>
             </a:extLst>
           </p:cNvPr>
@@ -5938,8 +6640,8 @@
         </p:nvSpPr>
         <p:spPr>
           <a:xfrm>
-            <a:off x="1318752" y="1036123"/>
-            <a:ext cx="2079523" cy="822960"/>
+            <a:off x="2598778" y="1240684"/>
+            <a:ext cx="2786340" cy="461665"/>
           </a:xfrm>
           <a:prstGeom prst="rect">
             <a:avLst/>
@@ -5947,29 +6649,24 @@
           <a:noFill/>
         </p:spPr>
         <p:txBody>
-          <a:bodyPr wrap="square" rtlCol="0">
+          <a:bodyPr wrap="none" rtlCol="0">
             <a:spAutoFit/>
           </a:bodyPr>
           <a:lstStyle/>
           <a:p>
-            <a:pPr algn="ctr"/>
-            <a:r>
-              <a:rPr lang="en-US" sz="2800" dirty="0"/>
-              <a:t>Total Customers</a:t>
-            </a:r>
-          </a:p>
-          <a:p>
-            <a:pPr algn="ctr"/>
-            <a:endParaRPr lang="en-US" sz="2800" dirty="0"/>
-          </a:p>
-        </p:txBody>
-      </p:sp>
-      <p:sp>
-        <p:nvSpPr>
-          <p:cNvPr id="5" name="TextBox 4">
+            <a:r>
+              <a:rPr lang="en-US" sz="2400" b="1"/>
+              <a:t>Repeat Customers</a:t>
+            </a:r>
+          </a:p>
+        </p:txBody>
+      </p:sp>
+      <p:sp>
+        <p:nvSpPr>
+          <p:cNvPr id="10" name="TextBox 9">
             <a:extLst>
               <a:ext uri="{FF2B5EF4-FFF2-40B4-BE49-F238E27FC236}">
-                <a16:creationId xmlns:a16="http://schemas.microsoft.com/office/drawing/2014/main" id="{19030DF6-52D1-B41F-8312-3C6939F260A5}"/>
+                <a16:creationId xmlns:a16="http://schemas.microsoft.com/office/drawing/2014/main" id="{9A195A27-4EA8-1721-3F96-BF7CA2341DA2}"/>
               </a:ext>
             </a:extLst>
           </p:cNvPr>
@@ -5978,8 +6675,8 @@
         </p:nvSpPr>
         <p:spPr>
           <a:xfrm>
-            <a:off x="1885466" y="1923911"/>
-            <a:ext cx="946093" cy="461665"/>
+            <a:off x="7138131" y="1243049"/>
+            <a:ext cx="2641877" cy="461665"/>
           </a:xfrm>
           <a:prstGeom prst="rect">
             <a:avLst/>
@@ -5993,18 +6690,57 @@
           <a:lstStyle/>
           <a:p>
             <a:r>
-              <a:rPr lang="en-US" sz="2400" dirty="0"/>
-              <a:t>4,339</a:t>
-            </a:r>
-          </a:p>
-        </p:txBody>
-      </p:sp>
-      <p:sp>
-        <p:nvSpPr>
-          <p:cNvPr id="6" name="TextBox 5">
+              <a:rPr lang="en-US" sz="2400" b="1"/>
+              <a:t>One-Time Buyers</a:t>
+            </a:r>
+          </a:p>
+        </p:txBody>
+      </p:sp>
+      <p:cxnSp>
+        <p:nvCxnSpPr>
+          <p:cNvPr id="12" name="Straight Connector 11">
             <a:extLst>
               <a:ext uri="{FF2B5EF4-FFF2-40B4-BE49-F238E27FC236}">
-                <a16:creationId xmlns:a16="http://schemas.microsoft.com/office/drawing/2014/main" id="{D2B0638C-2EBE-8C48-1D48-4103BE46E1C7}"/>
+                <a16:creationId xmlns:a16="http://schemas.microsoft.com/office/drawing/2014/main" id="{9AD999DD-5D6B-BE84-042E-B8208BB54C88}"/>
+              </a:ext>
+            </a:extLst>
+          </p:cNvPr>
+          <p:cNvCxnSpPr>
+            <a:cxnSpLocks/>
+          </p:cNvCxnSpPr>
+          <p:nvPr/>
+        </p:nvCxnSpPr>
+        <p:spPr>
+          <a:xfrm>
+            <a:off x="6096000" y="1205075"/>
+            <a:ext cx="0" cy="3124673"/>
+          </a:xfrm>
+          <a:prstGeom prst="line">
+            <a:avLst/>
+          </a:prstGeom>
+          <a:ln w="28575"/>
+        </p:spPr>
+        <p:style>
+          <a:lnRef idx="1">
+            <a:schemeClr val="accent1"/>
+          </a:lnRef>
+          <a:fillRef idx="0">
+            <a:schemeClr val="accent1"/>
+          </a:fillRef>
+          <a:effectRef idx="0">
+            <a:schemeClr val="accent1"/>
+          </a:effectRef>
+          <a:fontRef idx="minor">
+            <a:schemeClr val="tx1"/>
+          </a:fontRef>
+        </p:style>
+      </p:cxnSp>
+      <p:sp>
+        <p:nvSpPr>
+          <p:cNvPr id="14" name="TextBox 13">
+            <a:extLst>
+              <a:ext uri="{FF2B5EF4-FFF2-40B4-BE49-F238E27FC236}">
+                <a16:creationId xmlns:a16="http://schemas.microsoft.com/office/drawing/2014/main" id="{793DB77D-16B2-FCD6-9DDB-5501DFF05DC0}"/>
               </a:ext>
             </a:extLst>
           </p:cNvPr>
@@ -6013,8 +6749,8 @@
         </p:nvSpPr>
         <p:spPr>
           <a:xfrm>
-            <a:off x="4845276" y="1935463"/>
-            <a:ext cx="2162236" cy="461665"/>
+            <a:off x="3561944" y="2952948"/>
+            <a:ext cx="860008" cy="338554"/>
           </a:xfrm>
           <a:prstGeom prst="rect">
             <a:avLst/>
@@ -6022,24 +6758,24 @@
           <a:noFill/>
         </p:spPr>
         <p:txBody>
-          <a:bodyPr wrap="square" rtlCol="0">
+          <a:bodyPr wrap="square">
             <a:spAutoFit/>
           </a:bodyPr>
           <a:lstStyle/>
           <a:p>
             <a:r>
-              <a:rPr lang="en-US" sz="2400" dirty="0"/>
-              <a:t>$9,584,624.04</a:t>
-            </a:r>
-          </a:p>
-        </p:txBody>
-      </p:sp>
-      <p:sp>
-        <p:nvSpPr>
-          <p:cNvPr id="7" name="TextBox 6">
+              <a:rPr lang="en-US" sz="1600" b="1"/>
+              <a:t>$8.4M</a:t>
+            </a:r>
+          </a:p>
+        </p:txBody>
+      </p:sp>
+      <p:sp>
+        <p:nvSpPr>
+          <p:cNvPr id="17" name="TextBox 16">
             <a:extLst>
               <a:ext uri="{FF2B5EF4-FFF2-40B4-BE49-F238E27FC236}">
-                <a16:creationId xmlns:a16="http://schemas.microsoft.com/office/drawing/2014/main" id="{EC1CA0F9-683D-A436-EC70-F7C63BE8A5DD}"/>
+                <a16:creationId xmlns:a16="http://schemas.microsoft.com/office/drawing/2014/main" id="{4B69FF72-BFBE-406B-E11C-5713E52016B7}"/>
               </a:ext>
             </a:extLst>
           </p:cNvPr>
@@ -6048,8 +6784,8 @@
         </p:nvSpPr>
         <p:spPr>
           <a:xfrm>
-            <a:off x="4717027" y="1185993"/>
-            <a:ext cx="2418735" cy="523220"/>
+            <a:off x="7770049" y="2952948"/>
+            <a:ext cx="879674" cy="338554"/>
           </a:xfrm>
           <a:prstGeom prst="rect">
             <a:avLst/>
@@ -6057,25 +6793,24 @@
           <a:noFill/>
         </p:spPr>
         <p:txBody>
-          <a:bodyPr wrap="square" rtlCol="0">
+          <a:bodyPr wrap="square">
             <a:spAutoFit/>
           </a:bodyPr>
           <a:lstStyle/>
           <a:p>
-            <a:pPr algn="ctr"/>
-            <a:r>
-              <a:rPr lang="en-US" sz="2800" dirty="0"/>
-              <a:t>Total Revenue</a:t>
-            </a:r>
-          </a:p>
-        </p:txBody>
-      </p:sp>
-      <p:sp>
-        <p:nvSpPr>
-          <p:cNvPr id="8" name="TextBox 7">
+            <a:r>
+              <a:rPr lang="en-US" sz="1600" b="1"/>
+              <a:t>$600K</a:t>
+            </a:r>
+          </a:p>
+        </p:txBody>
+      </p:sp>
+      <p:sp>
+        <p:nvSpPr>
+          <p:cNvPr id="19" name="TextBox 18">
             <a:extLst>
               <a:ext uri="{FF2B5EF4-FFF2-40B4-BE49-F238E27FC236}">
-                <a16:creationId xmlns:a16="http://schemas.microsoft.com/office/drawing/2014/main" id="{33DCD7A4-7C7D-C0BE-1DEE-F02AA39B44CF}"/>
+                <a16:creationId xmlns:a16="http://schemas.microsoft.com/office/drawing/2014/main" id="{2D566DE3-CE67-B22D-1EBB-5C36BDD5B411}"/>
               </a:ext>
             </a:extLst>
           </p:cNvPr>
@@ -6084,8 +6819,8 @@
         </p:nvSpPr>
         <p:spPr>
           <a:xfrm>
-            <a:off x="9109883" y="1935463"/>
-            <a:ext cx="1107996" cy="461665"/>
+            <a:off x="3683738" y="3840029"/>
+            <a:ext cx="738214" cy="338554"/>
           </a:xfrm>
           <a:prstGeom prst="rect">
             <a:avLst/>
@@ -6093,24 +6828,24 @@
           <a:noFill/>
         </p:spPr>
         <p:txBody>
-          <a:bodyPr wrap="none" rtlCol="0">
+          <a:bodyPr wrap="square">
             <a:spAutoFit/>
           </a:bodyPr>
           <a:lstStyle/>
           <a:p>
             <a:r>
-              <a:rPr lang="en-US" sz="2400" dirty="0"/>
-              <a:t>$23.00</a:t>
-            </a:r>
-          </a:p>
-        </p:txBody>
-      </p:sp>
-      <p:sp>
-        <p:nvSpPr>
-          <p:cNvPr id="9" name="TextBox 8">
+              <a:rPr lang="en-US" sz="1600"/>
+              <a:t>2845</a:t>
+            </a:r>
+          </a:p>
+        </p:txBody>
+      </p:sp>
+      <p:sp>
+        <p:nvSpPr>
+          <p:cNvPr id="21" name="TextBox 20">
             <a:extLst>
               <a:ext uri="{FF2B5EF4-FFF2-40B4-BE49-F238E27FC236}">
-                <a16:creationId xmlns:a16="http://schemas.microsoft.com/office/drawing/2014/main" id="{EC19C215-1F45-049C-7C19-54EA642891B0}"/>
+                <a16:creationId xmlns:a16="http://schemas.microsoft.com/office/drawing/2014/main" id="{F6FDA69B-B0E0-68A4-6E3F-543C1D2F347F}"/>
               </a:ext>
             </a:extLst>
           </p:cNvPr>
@@ -6119,8 +6854,8 @@
         </p:nvSpPr>
         <p:spPr>
           <a:xfrm>
-            <a:off x="8454514" y="970550"/>
-            <a:ext cx="2418735" cy="954107"/>
+            <a:off x="7852237" y="3842394"/>
+            <a:ext cx="715297" cy="338554"/>
           </a:xfrm>
           <a:prstGeom prst="rect">
             <a:avLst/>
@@ -6128,6 +6863,111 @@
           <a:noFill/>
         </p:spPr>
         <p:txBody>
+          <a:bodyPr wrap="square">
+            <a:spAutoFit/>
+          </a:bodyPr>
+          <a:lstStyle/>
+          <a:p>
+            <a:r>
+              <a:rPr lang="en-US" sz="1600"/>
+              <a:t>1494</a:t>
+            </a:r>
+          </a:p>
+        </p:txBody>
+      </p:sp>
+      <p:sp>
+        <p:nvSpPr>
+          <p:cNvPr id="23" name="TextBox 22">
+            <a:extLst>
+              <a:ext uri="{FF2B5EF4-FFF2-40B4-BE49-F238E27FC236}">
+                <a16:creationId xmlns:a16="http://schemas.microsoft.com/office/drawing/2014/main" id="{35A26B54-C9CE-78D1-33AC-1545F78EA958}"/>
+              </a:ext>
+            </a:extLst>
+          </p:cNvPr>
+          <p:cNvSpPr txBox="1"/>
+          <p:nvPr/>
+        </p:nvSpPr>
+        <p:spPr>
+          <a:xfrm>
+            <a:off x="1635612" y="2973139"/>
+            <a:ext cx="1226120" cy="369332"/>
+          </a:xfrm>
+          <a:prstGeom prst="rect">
+            <a:avLst/>
+          </a:prstGeom>
+          <a:noFill/>
+        </p:spPr>
+        <p:txBody>
+          <a:bodyPr wrap="square">
+            <a:spAutoFit/>
+          </a:bodyPr>
+          <a:lstStyle/>
+          <a:p>
+            <a:r>
+              <a:rPr lang="en-US" b="1"/>
+              <a:t>Revenue</a:t>
+            </a:r>
+          </a:p>
+        </p:txBody>
+      </p:sp>
+      <p:sp>
+        <p:nvSpPr>
+          <p:cNvPr id="30" name="TextBox 29">
+            <a:extLst>
+              <a:ext uri="{FF2B5EF4-FFF2-40B4-BE49-F238E27FC236}">
+                <a16:creationId xmlns:a16="http://schemas.microsoft.com/office/drawing/2014/main" id="{CA0EE695-7346-D7BB-09AE-D0B4E0130873}"/>
+              </a:ext>
+            </a:extLst>
+          </p:cNvPr>
+          <p:cNvSpPr txBox="1"/>
+          <p:nvPr/>
+        </p:nvSpPr>
+        <p:spPr>
+          <a:xfrm>
+            <a:off x="1508538" y="3686140"/>
+            <a:ext cx="1584298" cy="646331"/>
+          </a:xfrm>
+          <a:prstGeom prst="rect">
+            <a:avLst/>
+          </a:prstGeom>
+          <a:noFill/>
+        </p:spPr>
+        <p:txBody>
+          <a:bodyPr wrap="square">
+            <a:spAutoFit/>
+          </a:bodyPr>
+          <a:lstStyle/>
+          <a:p>
+            <a:r>
+              <a:rPr lang="en-US" b="1"/>
+              <a:t> Number of Customers</a:t>
+            </a:r>
+          </a:p>
+        </p:txBody>
+      </p:sp>
+      <p:sp>
+        <p:nvSpPr>
+          <p:cNvPr id="31" name="TextBox 30">
+            <a:extLst>
+              <a:ext uri="{FF2B5EF4-FFF2-40B4-BE49-F238E27FC236}">
+                <a16:creationId xmlns:a16="http://schemas.microsoft.com/office/drawing/2014/main" id="{DC0E58CB-8570-1F30-D90F-97EA9E5FAFB8}"/>
+              </a:ext>
+            </a:extLst>
+          </p:cNvPr>
+          <p:cNvSpPr txBox="1"/>
+          <p:nvPr/>
+        </p:nvSpPr>
+        <p:spPr>
+          <a:xfrm>
+            <a:off x="1003413" y="4821928"/>
+            <a:ext cx="10185174" cy="830997"/>
+          </a:xfrm>
+          <a:prstGeom prst="rect">
+            <a:avLst/>
+          </a:prstGeom>
+          <a:noFill/>
+        </p:spPr>
+        <p:txBody>
           <a:bodyPr wrap="square" rtlCol="0">
             <a:spAutoFit/>
           </a:bodyPr>
@@ -6135,8 +6975,8 @@
           <a:p>
             <a:pPr algn="ctr"/>
             <a:r>
-              <a:rPr lang="en-US" sz="2800" dirty="0"/>
-              <a:t>Avg Revenue Per Order</a:t>
+              <a:rPr lang="en-US" sz="2400"/>
+              <a:t>Repeat Customers generate 93% of revenue, making retention a crucial driver of business growth</a:t>
             </a:r>
           </a:p>
         </p:txBody>
@@ -6145,6 +6985,86 @@
     <p:extLst>
       <p:ext uri="{BB962C8B-B14F-4D97-AF65-F5344CB8AC3E}">
         <p14:creationId xmlns:p14="http://schemas.microsoft.com/office/powerpoint/2010/main" val="2863434639"/>
+      </p:ext>
+    </p:extLst>
+  </p:cSld>
+  <p:clrMapOvr>
+    <a:masterClrMapping/>
+  </p:clrMapOvr>
+</p:sld>
+</file>
+
+<file path=ppt/slides/slide3.xml><?xml version="1.0" encoding="utf-8"?>
+<p:sld xmlns:a="http://schemas.openxmlformats.org/drawingml/2006/main" xmlns:r="http://schemas.openxmlformats.org/officeDocument/2006/relationships" xmlns:p="http://schemas.openxmlformats.org/presentationml/2006/main">
+  <p:cSld>
+    <p:spTree>
+      <p:nvGrpSpPr>
+        <p:cNvPr id="1" name=""/>
+        <p:cNvGrpSpPr/>
+        <p:nvPr/>
+      </p:nvGrpSpPr>
+      <p:grpSpPr>
+        <a:xfrm>
+          <a:off x="0" y="0"/>
+          <a:ext cx="0" cy="0"/>
+          <a:chOff x="0" y="0"/>
+          <a:chExt cx="0" cy="0"/>
+        </a:xfrm>
+      </p:grpSpPr>
+      <p:sp>
+        <p:nvSpPr>
+          <p:cNvPr id="2" name="Title 1">
+            <a:extLst>
+              <a:ext uri="{FF2B5EF4-FFF2-40B4-BE49-F238E27FC236}">
+                <a16:creationId xmlns:a16="http://schemas.microsoft.com/office/drawing/2014/main" id="{1B15FACE-2255-138A-5949-69A528584C32}"/>
+              </a:ext>
+            </a:extLst>
+          </p:cNvPr>
+          <p:cNvSpPr>
+            <a:spLocks noGrp="1"/>
+          </p:cNvSpPr>
+          <p:nvPr>
+            <p:ph type="title"/>
+          </p:nvPr>
+        </p:nvSpPr>
+        <p:spPr/>
+        <p:txBody>
+          <a:bodyPr/>
+          <a:lstStyle/>
+          <a:p>
+            <a:endParaRPr lang="en-US"/>
+          </a:p>
+        </p:txBody>
+      </p:sp>
+      <p:sp>
+        <p:nvSpPr>
+          <p:cNvPr id="3" name="Content Placeholder 2">
+            <a:extLst>
+              <a:ext uri="{FF2B5EF4-FFF2-40B4-BE49-F238E27FC236}">
+                <a16:creationId xmlns:a16="http://schemas.microsoft.com/office/drawing/2014/main" id="{CC14CC32-C534-49C6-FCB1-378613075213}"/>
+              </a:ext>
+            </a:extLst>
+          </p:cNvPr>
+          <p:cNvSpPr>
+            <a:spLocks noGrp="1"/>
+          </p:cNvSpPr>
+          <p:nvPr>
+            <p:ph idx="1"/>
+          </p:nvPr>
+        </p:nvSpPr>
+        <p:spPr/>
+        <p:txBody>
+          <a:bodyPr/>
+          <a:lstStyle/>
+          <a:p>
+            <a:endParaRPr lang="en-US"/>
+          </a:p>
+        </p:txBody>
+      </p:sp>
+    </p:spTree>
+    <p:extLst>
+      <p:ext uri="{BB962C8B-B14F-4D97-AF65-F5344CB8AC3E}">
+        <p14:creationId xmlns:p14="http://schemas.microsoft.com/office/powerpoint/2010/main" val="1201758319"/>
       </p:ext>
     </p:extLst>
   </p:cSld>
@@ -6409,4 +7329,319 @@
     </a:ext>
   </a:extLst>
 </a:theme>
+</file>
+
+<file path=ppt/theme/theme2.xml><?xml version="1.0" encoding="utf-8"?>
+<a:theme xmlns:a="http://schemas.openxmlformats.org/drawingml/2006/main" name="Office Theme">
+  <a:themeElements>
+    <a:clrScheme name="Office">
+      <a:dk1>
+        <a:sysClr val="windowText" lastClr="000000"/>
+      </a:dk1>
+      <a:lt1>
+        <a:sysClr val="window" lastClr="FFFFFF"/>
+      </a:lt1>
+      <a:dk2>
+        <a:srgbClr val="0E2841"/>
+      </a:dk2>
+      <a:lt2>
+        <a:srgbClr val="E8E8E8"/>
+      </a:lt2>
+      <a:accent1>
+        <a:srgbClr val="156082"/>
+      </a:accent1>
+      <a:accent2>
+        <a:srgbClr val="E97132"/>
+      </a:accent2>
+      <a:accent3>
+        <a:srgbClr val="196B24"/>
+      </a:accent3>
+      <a:accent4>
+        <a:srgbClr val="0F9ED5"/>
+      </a:accent4>
+      <a:accent5>
+        <a:srgbClr val="A02B93"/>
+      </a:accent5>
+      <a:accent6>
+        <a:srgbClr val="4EA72E"/>
+      </a:accent6>
+      <a:hlink>
+        <a:srgbClr val="467886"/>
+      </a:hlink>
+      <a:folHlink>
+        <a:srgbClr val="96607D"/>
+      </a:folHlink>
+    </a:clrScheme>
+    <a:fontScheme name="Office">
+      <a:majorFont>
+        <a:latin typeface="Aptos Display" panose="02110004020202020204"/>
+        <a:ea typeface=""/>
+        <a:cs typeface=""/>
+        <a:font script="Jpan" typeface="游ゴシック Light"/>
+        <a:font script="Hang" typeface="맑은 고딕"/>
+        <a:font script="Hans" typeface="等线 Light"/>
+        <a:font script="Hant" typeface="新細明體"/>
+        <a:font script="Arab" typeface="Times New Roman"/>
+        <a:font script="Hebr" typeface="Times New Roman"/>
+        <a:font script="Thai" typeface="Angsana New"/>
+        <a:font script="Ethi" typeface="Nyala"/>
+        <a:font script="Beng" typeface="Vrinda"/>
+        <a:font script="Gujr" typeface="Shruti"/>
+        <a:font script="Khmr" typeface="MoolBoran"/>
+        <a:font script="Knda" typeface="Tunga"/>
+        <a:font script="Guru" typeface="Raavi"/>
+        <a:font script="Cans" typeface="Euphemia"/>
+        <a:font script="Cher" typeface="Plantagenet Cherokee"/>
+        <a:font script="Yiii" typeface="Microsoft Yi Baiti"/>
+        <a:font script="Tibt" typeface="Microsoft Himalaya"/>
+        <a:font script="Thaa" typeface="MV Boli"/>
+        <a:font script="Deva" typeface="Mangal"/>
+        <a:font script="Telu" typeface="Gautami"/>
+        <a:font script="Taml" typeface="Latha"/>
+        <a:font script="Syrc" typeface="Estrangelo Edessa"/>
+        <a:font script="Orya" typeface="Kalinga"/>
+        <a:font script="Mlym" typeface="Kartika"/>
+        <a:font script="Laoo" typeface="DokChampa"/>
+        <a:font script="Sinh" typeface="Iskoola Pota"/>
+        <a:font script="Mong" typeface="Mongolian Baiti"/>
+        <a:font script="Viet" typeface="Times New Roman"/>
+        <a:font script="Uigh" typeface="Microsoft Uighur"/>
+        <a:font script="Geor" typeface="Sylfaen"/>
+        <a:font script="Armn" typeface="Arial"/>
+        <a:font script="Bugi" typeface="Leelawadee UI"/>
+        <a:font script="Bopo" typeface="Microsoft JhengHei"/>
+        <a:font script="Java" typeface="Javanese Text"/>
+        <a:font script="Lisu" typeface="Segoe UI"/>
+        <a:font script="Mymr" typeface="Myanmar Text"/>
+        <a:font script="Nkoo" typeface="Ebrima"/>
+        <a:font script="Olck" typeface="Nirmala UI"/>
+        <a:font script="Osma" typeface="Ebrima"/>
+        <a:font script="Phag" typeface="Phagspa"/>
+        <a:font script="Syrn" typeface="Estrangelo Edessa"/>
+        <a:font script="Syrj" typeface="Estrangelo Edessa"/>
+        <a:font script="Syre" typeface="Estrangelo Edessa"/>
+        <a:font script="Sora" typeface="Nirmala UI"/>
+        <a:font script="Tale" typeface="Microsoft Tai Le"/>
+        <a:font script="Talu" typeface="Microsoft New Tai Lue"/>
+        <a:font script="Tfng" typeface="Ebrima"/>
+      </a:majorFont>
+      <a:minorFont>
+        <a:latin typeface="Aptos" panose="02110004020202020204"/>
+        <a:ea typeface=""/>
+        <a:cs typeface=""/>
+        <a:font script="Jpan" typeface="游ゴシック"/>
+        <a:font script="Hang" typeface="맑은 고딕"/>
+        <a:font script="Hans" typeface="等线"/>
+        <a:font script="Hant" typeface="新細明體"/>
+        <a:font script="Arab" typeface="Arial"/>
+        <a:font script="Hebr" typeface="Arial"/>
+        <a:font script="Thai" typeface="Cordia New"/>
+        <a:font script="Ethi" typeface="Nyala"/>
+        <a:font script="Beng" typeface="Vrinda"/>
+        <a:font script="Gujr" typeface="Shruti"/>
+        <a:font script="Khmr" typeface="DaunPenh"/>
+        <a:font script="Knda" typeface="Tunga"/>
+        <a:font script="Guru" typeface="Raavi"/>
+        <a:font script="Cans" typeface="Euphemia"/>
+        <a:font script="Cher" typeface="Plantagenet Cherokee"/>
+        <a:font script="Yiii" typeface="Microsoft Yi Baiti"/>
+        <a:font script="Tibt" typeface="Microsoft Himalaya"/>
+        <a:font script="Thaa" typeface="MV Boli"/>
+        <a:font script="Deva" typeface="Mangal"/>
+        <a:font script="Telu" typeface="Gautami"/>
+        <a:font script="Taml" typeface="Latha"/>
+        <a:font script="Syrc" typeface="Estrangelo Edessa"/>
+        <a:font script="Orya" typeface="Kalinga"/>
+        <a:font script="Mlym" typeface="Kartika"/>
+        <a:font script="Laoo" typeface="DokChampa"/>
+        <a:font script="Sinh" typeface="Iskoola Pota"/>
+        <a:font script="Mong" typeface="Mongolian Baiti"/>
+        <a:font script="Viet" typeface="Arial"/>
+        <a:font script="Uigh" typeface="Microsoft Uighur"/>
+        <a:font script="Geor" typeface="Sylfaen"/>
+        <a:font script="Armn" typeface="Arial"/>
+        <a:font script="Bugi" typeface="Leelawadee UI"/>
+        <a:font script="Bopo" typeface="Microsoft JhengHei"/>
+        <a:font script="Java" typeface="Javanese Text"/>
+        <a:font script="Lisu" typeface="Segoe UI"/>
+        <a:font script="Mymr" typeface="Myanmar Text"/>
+        <a:font script="Nkoo" typeface="Ebrima"/>
+        <a:font script="Olck" typeface="Nirmala UI"/>
+        <a:font script="Osma" typeface="Ebrima"/>
+        <a:font script="Phag" typeface="Phagspa"/>
+        <a:font script="Syrn" typeface="Estrangelo Edessa"/>
+        <a:font script="Syrj" typeface="Estrangelo Edessa"/>
+        <a:font script="Syre" typeface="Estrangelo Edessa"/>
+        <a:font script="Sora" typeface="Nirmala UI"/>
+        <a:font script="Tale" typeface="Microsoft Tai Le"/>
+        <a:font script="Talu" typeface="Microsoft New Tai Lue"/>
+        <a:font script="Tfng" typeface="Ebrima"/>
+      </a:minorFont>
+    </a:fontScheme>
+    <a:fmtScheme name="Office">
+      <a:fillStyleLst>
+        <a:solidFill>
+          <a:schemeClr val="phClr"/>
+        </a:solidFill>
+        <a:gradFill rotWithShape="1">
+          <a:gsLst>
+            <a:gs pos="0">
+              <a:schemeClr val="phClr">
+                <a:lumMod val="110000"/>
+                <a:satMod val="105000"/>
+                <a:tint val="67000"/>
+              </a:schemeClr>
+            </a:gs>
+            <a:gs pos="50000">
+              <a:schemeClr val="phClr">
+                <a:lumMod val="105000"/>
+                <a:satMod val="103000"/>
+                <a:tint val="73000"/>
+              </a:schemeClr>
+            </a:gs>
+            <a:gs pos="100000">
+              <a:schemeClr val="phClr">
+                <a:lumMod val="105000"/>
+                <a:satMod val="109000"/>
+                <a:tint val="81000"/>
+              </a:schemeClr>
+            </a:gs>
+          </a:gsLst>
+          <a:lin ang="5400000" scaled="0"/>
+        </a:gradFill>
+        <a:gradFill rotWithShape="1">
+          <a:gsLst>
+            <a:gs pos="0">
+              <a:schemeClr val="phClr">
+                <a:satMod val="103000"/>
+                <a:lumMod val="102000"/>
+                <a:tint val="94000"/>
+              </a:schemeClr>
+            </a:gs>
+            <a:gs pos="50000">
+              <a:schemeClr val="phClr">
+                <a:satMod val="110000"/>
+                <a:lumMod val="100000"/>
+                <a:shade val="100000"/>
+              </a:schemeClr>
+            </a:gs>
+            <a:gs pos="100000">
+              <a:schemeClr val="phClr">
+                <a:lumMod val="99000"/>
+                <a:satMod val="120000"/>
+                <a:shade val="78000"/>
+              </a:schemeClr>
+            </a:gs>
+          </a:gsLst>
+          <a:lin ang="5400000" scaled="0"/>
+        </a:gradFill>
+      </a:fillStyleLst>
+      <a:lnStyleLst>
+        <a:ln w="12700" cap="flat" cmpd="sng" algn="ctr">
+          <a:solidFill>
+            <a:schemeClr val="phClr"/>
+          </a:solidFill>
+          <a:prstDash val="solid"/>
+          <a:miter lim="800000"/>
+        </a:ln>
+        <a:ln w="19050" cap="flat" cmpd="sng" algn="ctr">
+          <a:solidFill>
+            <a:schemeClr val="phClr"/>
+          </a:solidFill>
+          <a:prstDash val="solid"/>
+          <a:miter lim="800000"/>
+        </a:ln>
+        <a:ln w="25400" cap="flat" cmpd="sng" algn="ctr">
+          <a:solidFill>
+            <a:schemeClr val="phClr"/>
+          </a:solidFill>
+          <a:prstDash val="solid"/>
+          <a:miter lim="800000"/>
+        </a:ln>
+      </a:lnStyleLst>
+      <a:effectStyleLst>
+        <a:effectStyle>
+          <a:effectLst/>
+        </a:effectStyle>
+        <a:effectStyle>
+          <a:effectLst/>
+        </a:effectStyle>
+        <a:effectStyle>
+          <a:effectLst>
+            <a:outerShdw blurRad="57150" dist="19050" dir="5400000" algn="ctr" rotWithShape="0">
+              <a:srgbClr val="000000">
+                <a:alpha val="63000"/>
+              </a:srgbClr>
+            </a:outerShdw>
+          </a:effectLst>
+        </a:effectStyle>
+      </a:effectStyleLst>
+      <a:bgFillStyleLst>
+        <a:solidFill>
+          <a:schemeClr val="phClr"/>
+        </a:solidFill>
+        <a:solidFill>
+          <a:schemeClr val="phClr">
+            <a:tint val="95000"/>
+            <a:satMod val="170000"/>
+          </a:schemeClr>
+        </a:solidFill>
+        <a:gradFill rotWithShape="1">
+          <a:gsLst>
+            <a:gs pos="0">
+              <a:schemeClr val="phClr">
+                <a:tint val="93000"/>
+                <a:satMod val="150000"/>
+                <a:shade val="98000"/>
+                <a:lumMod val="102000"/>
+              </a:schemeClr>
+            </a:gs>
+            <a:gs pos="50000">
+              <a:schemeClr val="phClr">
+                <a:tint val="98000"/>
+                <a:satMod val="130000"/>
+                <a:shade val="90000"/>
+                <a:lumMod val="103000"/>
+              </a:schemeClr>
+            </a:gs>
+            <a:gs pos="100000">
+              <a:schemeClr val="phClr">
+                <a:shade val="63000"/>
+                <a:satMod val="120000"/>
+              </a:schemeClr>
+            </a:gs>
+          </a:gsLst>
+          <a:lin ang="5400000" scaled="0"/>
+        </a:gradFill>
+      </a:bgFillStyleLst>
+    </a:fmtScheme>
+  </a:themeElements>
+  <a:objectDefaults>
+    <a:lnDef>
+      <a:spPr/>
+      <a:bodyPr/>
+      <a:lstStyle/>
+      <a:style>
+        <a:lnRef idx="2">
+          <a:schemeClr val="accent1"/>
+        </a:lnRef>
+        <a:fillRef idx="0">
+          <a:schemeClr val="accent1"/>
+        </a:fillRef>
+        <a:effectRef idx="1">
+          <a:schemeClr val="accent1"/>
+        </a:effectRef>
+        <a:fontRef idx="minor">
+          <a:schemeClr val="tx1"/>
+        </a:fontRef>
+      </a:style>
+    </a:lnDef>
+  </a:objectDefaults>
+  <a:extraClrSchemeLst/>
+  <a:extLst>
+    <a:ext uri="{05A4C25C-085E-4340-85A3-A5531E510DB2}">
+      <thm15:themeFamily xmlns:thm15="http://schemas.microsoft.com/office/thememl/2012/main" name="Office Theme" id="{2E142A2C-CD16-42D6-873A-C26D2A0506FA}" vid="{1BDDFF52-6CD6-40A5-AB3C-68EB2F1E4D0A}"/>
+    </a:ext>
+  </a:extLst>
+</a:theme>
 </file>
</xml_diff>

<commit_message>
Finished Presenting Churn Window, working on using RFM and CHurn to push for action
</commit_message>
<xml_diff>
--- a/Customer Retention Analysis.pptx
+++ b/Customer Retention Analysis.pptx
@@ -5,7 +5,7 @@
     <p:sldMasterId id="2147483660" r:id="rId1"/>
   </p:sldMasterIdLst>
   <p:notesMasterIdLst>
-    <p:notesMasterId r:id="rId8"/>
+    <p:notesMasterId r:id="rId9"/>
   </p:notesMasterIdLst>
   <p:sldIdLst>
     <p:sldId id="256" r:id="rId2"/>
@@ -14,6 +14,7 @@
     <p:sldId id="259" r:id="rId5"/>
     <p:sldId id="260" r:id="rId6"/>
     <p:sldId id="261" r:id="rId7"/>
+    <p:sldId id="262" r:id="rId8"/>
   </p:sldIdLst>
   <p:sldSz cx="12192000" cy="6858000"/>
   <p:notesSz cx="6858000" cy="9144000"/>
@@ -123,7 +124,7 @@
 <file path=ppt/revisionInfo.xml><?xml version="1.0" encoding="utf-8"?>
 <p1510:revInfo xmlns:a="http://schemas.openxmlformats.org/drawingml/2006/main" xmlns:r="http://schemas.openxmlformats.org/officeDocument/2006/relationships" xmlns:p1510="http://schemas.microsoft.com/office/powerpoint/2015/10/main">
   <p1510:revLst>
-    <p1510:client id="{708AB096-502C-4CC0-9240-ACA9084E787F}" v="2722" dt="2025-12-14T06:01:05.040"/>
+    <p1510:client id="{708AB096-502C-4CC0-9240-ACA9084E787F}" v="2723" dt="2025-12-15T05:03:49.977"/>
   </p1510:revLst>
 </p1510:revInfo>
 </file>
@@ -133,7 +134,7 @@
   <pc:docChgLst>
     <pc:chgData name="Henry Vo" userId="c18cca123e130253" providerId="LiveId" clId="{CBED1F73-AEB6-48AF-B30C-D6CFC8A51246}"/>
     <pc:docChg chg="undo custSel addSld modSld">
-      <pc:chgData name="Henry Vo" userId="c18cca123e130253" providerId="LiveId" clId="{CBED1F73-AEB6-48AF-B30C-D6CFC8A51246}" dt="2025-12-14T06:01:11.482" v="3630" actId="20577"/>
+      <pc:chgData name="Henry Vo" userId="c18cca123e130253" providerId="LiveId" clId="{CBED1F73-AEB6-48AF-B30C-D6CFC8A51246}" dt="2025-12-15T05:15:40.175" v="4174" actId="113"/>
       <pc:docMkLst>
         <pc:docMk/>
       </pc:docMkLst>
@@ -256,13 +257,13 @@
         </pc:cxnChg>
       </pc:sldChg>
       <pc:sldChg chg="addSp delSp modSp new mod">
-        <pc:chgData name="Henry Vo" userId="c18cca123e130253" providerId="LiveId" clId="{CBED1F73-AEB6-48AF-B30C-D6CFC8A51246}" dt="2025-12-10T15:13:53.914" v="2911" actId="1076"/>
+        <pc:chgData name="Henry Vo" userId="c18cca123e130253" providerId="LiveId" clId="{CBED1F73-AEB6-48AF-B30C-D6CFC8A51246}" dt="2025-12-15T05:14:27.898" v="4156" actId="1076"/>
         <pc:sldMkLst>
           <pc:docMk/>
           <pc:sldMk cId="1201758319" sldId="258"/>
         </pc:sldMkLst>
         <pc:spChg chg="add mod">
-          <ac:chgData name="Henry Vo" userId="c18cca123e130253" providerId="LiveId" clId="{CBED1F73-AEB6-48AF-B30C-D6CFC8A51246}" dt="2025-12-10T15:13:53.914" v="2911" actId="1076"/>
+          <ac:chgData name="Henry Vo" userId="c18cca123e130253" providerId="LiveId" clId="{CBED1F73-AEB6-48AF-B30C-D6CFC8A51246}" dt="2025-12-15T05:14:27.898" v="4156" actId="1076"/>
           <ac:spMkLst>
             <pc:docMk/>
             <pc:sldMk cId="1201758319" sldId="258"/>
@@ -270,7 +271,7 @@
           </ac:spMkLst>
         </pc:spChg>
         <pc:spChg chg="add mod">
-          <ac:chgData name="Henry Vo" userId="c18cca123e130253" providerId="LiveId" clId="{CBED1F73-AEB6-48AF-B30C-D6CFC8A51246}" dt="2025-12-09T04:08:36.021" v="1962" actId="20577"/>
+          <ac:chgData name="Henry Vo" userId="c18cca123e130253" providerId="LiveId" clId="{CBED1F73-AEB6-48AF-B30C-D6CFC8A51246}" dt="2025-12-15T05:14:25.113" v="4155" actId="1076"/>
           <ac:spMkLst>
             <pc:docMk/>
             <pc:sldMk cId="1201758319" sldId="258"/>
@@ -295,7 +296,7 @@
         </pc:graphicFrameChg>
       </pc:sldChg>
       <pc:sldChg chg="addSp delSp modSp new mod">
-        <pc:chgData name="Henry Vo" userId="c18cca123e130253" providerId="LiveId" clId="{CBED1F73-AEB6-48AF-B30C-D6CFC8A51246}" dt="2025-12-10T15:12:49.657" v="2746" actId="1076"/>
+        <pc:chgData name="Henry Vo" userId="c18cca123e130253" providerId="LiveId" clId="{CBED1F73-AEB6-48AF-B30C-D6CFC8A51246}" dt="2025-12-15T05:15:40.175" v="4174" actId="113"/>
         <pc:sldMkLst>
           <pc:docMk/>
           <pc:sldMk cId="2199859215" sldId="259"/>
@@ -309,7 +310,7 @@
           </ac:spMkLst>
         </pc:spChg>
         <pc:spChg chg="add mod">
-          <ac:chgData name="Henry Vo" userId="c18cca123e130253" providerId="LiveId" clId="{CBED1F73-AEB6-48AF-B30C-D6CFC8A51246}" dt="2025-12-10T15:12:49.657" v="2746" actId="1076"/>
+          <ac:chgData name="Henry Vo" userId="c18cca123e130253" providerId="LiveId" clId="{CBED1F73-AEB6-48AF-B30C-D6CFC8A51246}" dt="2025-12-15T05:15:40.175" v="4174" actId="113"/>
           <ac:spMkLst>
             <pc:docMk/>
             <pc:sldMk cId="2199859215" sldId="259"/>
@@ -334,7 +335,7 @@
         </pc:picChg>
       </pc:sldChg>
       <pc:sldChg chg="addSp delSp modSp new mod">
-        <pc:chgData name="Henry Vo" userId="c18cca123e130253" providerId="LiveId" clId="{CBED1F73-AEB6-48AF-B30C-D6CFC8A51246}" dt="2025-12-10T15:46:37.961" v="3578" actId="20577"/>
+        <pc:chgData name="Henry Vo" userId="c18cca123e130253" providerId="LiveId" clId="{CBED1F73-AEB6-48AF-B30C-D6CFC8A51246}" dt="2025-12-15T05:15:32.675" v="4172" actId="113"/>
         <pc:sldMkLst>
           <pc:docMk/>
           <pc:sldMk cId="3564352135" sldId="260"/>
@@ -348,7 +349,7 @@
           </ac:spMkLst>
         </pc:spChg>
         <pc:spChg chg="add mod">
-          <ac:chgData name="Henry Vo" userId="c18cca123e130253" providerId="LiveId" clId="{CBED1F73-AEB6-48AF-B30C-D6CFC8A51246}" dt="2025-12-10T15:43:46.124" v="3572" actId="1076"/>
+          <ac:chgData name="Henry Vo" userId="c18cca123e130253" providerId="LiveId" clId="{CBED1F73-AEB6-48AF-B30C-D6CFC8A51246}" dt="2025-12-15T05:15:26.980" v="4171" actId="113"/>
           <ac:spMkLst>
             <pc:docMk/>
             <pc:sldMk cId="3564352135" sldId="260"/>
@@ -356,7 +357,7 @@
           </ac:spMkLst>
         </pc:spChg>
         <pc:spChg chg="add mod">
-          <ac:chgData name="Henry Vo" userId="c18cca123e130253" providerId="LiveId" clId="{CBED1F73-AEB6-48AF-B30C-D6CFC8A51246}" dt="2025-12-10T15:43:49.194" v="3573" actId="14100"/>
+          <ac:chgData name="Henry Vo" userId="c18cca123e130253" providerId="LiveId" clId="{CBED1F73-AEB6-48AF-B30C-D6CFC8A51246}" dt="2025-12-15T05:15:32.675" v="4172" actId="113"/>
           <ac:spMkLst>
             <pc:docMk/>
             <pc:sldMk cId="3564352135" sldId="260"/>
@@ -364,7 +365,7 @@
           </ac:spMkLst>
         </pc:spChg>
         <pc:picChg chg="add del mod">
-          <ac:chgData name="Henry Vo" userId="c18cca123e130253" providerId="LiveId" clId="{CBED1F73-AEB6-48AF-B30C-D6CFC8A51246}" dt="2025-12-10T15:44:13.628" v="3575" actId="478"/>
+          <ac:chgData name="Henry Vo" userId="c18cca123e130253" providerId="LiveId" clId="{CBED1F73-AEB6-48AF-B30C-D6CFC8A51246}" dt="2025-12-15T05:10:16.103" v="4140" actId="1076"/>
           <ac:picMkLst>
             <pc:docMk/>
             <pc:sldMk cId="3564352135" sldId="260"/>
@@ -373,7 +374,7 @@
         </pc:picChg>
       </pc:sldChg>
       <pc:sldChg chg="addSp delSp modSp new mod">
-        <pc:chgData name="Henry Vo" userId="c18cca123e130253" providerId="LiveId" clId="{CBED1F73-AEB6-48AF-B30C-D6CFC8A51246}" dt="2025-12-14T06:01:11.482" v="3630" actId="20577"/>
+        <pc:chgData name="Henry Vo" userId="c18cca123e130253" providerId="LiveId" clId="{CBED1F73-AEB6-48AF-B30C-D6CFC8A51246}" dt="2025-12-15T05:15:16.388" v="4168" actId="113"/>
         <pc:sldMkLst>
           <pc:docMk/>
           <pc:sldMk cId="3083110177" sldId="261"/>
@@ -403,13 +404,60 @@
           </ac:spMkLst>
         </pc:spChg>
         <pc:spChg chg="add mod">
-          <ac:chgData name="Henry Vo" userId="c18cca123e130253" providerId="LiveId" clId="{CBED1F73-AEB6-48AF-B30C-D6CFC8A51246}" dt="2025-12-14T06:01:11.482" v="3630" actId="20577"/>
+          <ac:chgData name="Henry Vo" userId="c18cca123e130253" providerId="LiveId" clId="{CBED1F73-AEB6-48AF-B30C-D6CFC8A51246}" dt="2025-12-15T05:03:30.850" v="3654" actId="20577"/>
           <ac:spMkLst>
             <pc:docMk/>
             <pc:sldMk cId="3083110177" sldId="261"/>
             <ac:spMk id="5" creationId="{169B1C97-AA5B-69E9-2059-E2997052D437}"/>
           </ac:spMkLst>
         </pc:spChg>
+        <pc:spChg chg="add mod">
+          <ac:chgData name="Henry Vo" userId="c18cca123e130253" providerId="LiveId" clId="{CBED1F73-AEB6-48AF-B30C-D6CFC8A51246}" dt="2025-12-15T05:15:16.388" v="4168" actId="113"/>
+          <ac:spMkLst>
+            <pc:docMk/>
+            <pc:sldMk cId="3083110177" sldId="261"/>
+            <ac:spMk id="7" creationId="{142FC0C8-9160-88FE-AEBB-0AA357C23B78}"/>
+          </ac:spMkLst>
+        </pc:spChg>
+        <pc:picChg chg="add del mod">
+          <ac:chgData name="Henry Vo" userId="c18cca123e130253" providerId="LiveId" clId="{CBED1F73-AEB6-48AF-B30C-D6CFC8A51246}" dt="2025-12-15T05:01:48.666" v="3635" actId="478"/>
+          <ac:picMkLst>
+            <pc:docMk/>
+            <pc:sldMk cId="3083110177" sldId="261"/>
+            <ac:picMk id="3" creationId="{1E43CEDE-26D2-785F-ADE8-298D4196E218}"/>
+          </ac:picMkLst>
+        </pc:picChg>
+        <pc:picChg chg="add del mod modCrop">
+          <ac:chgData name="Henry Vo" userId="c18cca123e130253" providerId="LiveId" clId="{CBED1F73-AEB6-48AF-B30C-D6CFC8A51246}" dt="2025-12-15T05:13:07.888" v="4147" actId="478"/>
+          <ac:picMkLst>
+            <pc:docMk/>
+            <pc:sldMk cId="3083110177" sldId="261"/>
+            <ac:picMk id="6" creationId="{7AD20D24-1A39-E8D2-A488-C3AC8B13991F}"/>
+          </ac:picMkLst>
+        </pc:picChg>
+        <pc:picChg chg="add del">
+          <ac:chgData name="Henry Vo" userId="c18cca123e130253" providerId="LiveId" clId="{CBED1F73-AEB6-48AF-B30C-D6CFC8A51246}" dt="2025-12-15T05:13:06.941" v="4146" actId="22"/>
+          <ac:picMkLst>
+            <pc:docMk/>
+            <pc:sldMk cId="3083110177" sldId="261"/>
+            <ac:picMk id="9" creationId="{3B5718B7-8060-2485-AEA3-A6796F58A697}"/>
+          </ac:picMkLst>
+        </pc:picChg>
+        <pc:picChg chg="add mod">
+          <ac:chgData name="Henry Vo" userId="c18cca123e130253" providerId="LiveId" clId="{CBED1F73-AEB6-48AF-B30C-D6CFC8A51246}" dt="2025-12-15T05:15:05.875" v="4163" actId="1076"/>
+          <ac:picMkLst>
+            <pc:docMk/>
+            <pc:sldMk cId="3083110177" sldId="261"/>
+            <ac:picMk id="11" creationId="{43484889-9244-8A37-1EF2-2AA451491DCB}"/>
+          </ac:picMkLst>
+        </pc:picChg>
+      </pc:sldChg>
+      <pc:sldChg chg="new">
+        <pc:chgData name="Henry Vo" userId="c18cca123e130253" providerId="LiveId" clId="{CBED1F73-AEB6-48AF-B30C-D6CFC8A51246}" dt="2025-12-15T05:14:43.825" v="4157" actId="680"/>
+        <pc:sldMkLst>
+          <pc:docMk/>
+          <pc:sldMk cId="3533779975" sldId="262"/>
+        </pc:sldMkLst>
       </pc:sldChg>
     </pc:docChg>
   </pc:docChgLst>
@@ -1877,7 +1925,7 @@
           <a:p>
             <a:fld id="{9C049790-B49D-4D8D-B628-59414A006FDF}" type="datetimeFigureOut">
               <a:rPr lang="en-US" smtClean="0"/>
-              <a:t>12/13/2025</a:t>
+              <a:t>12/14/2025</a:t>
             </a:fld>
             <a:endParaRPr lang="en-US"/>
           </a:p>
@@ -3088,7 +3136,7 @@
           <a:p>
             <a:fld id="{74411A3F-4DB3-47ED-809A-CD27B21BFB64}" type="datetimeFigureOut">
               <a:rPr lang="en-US" smtClean="0"/>
-              <a:t>12/13/2025</a:t>
+              <a:t>12/14/2025</a:t>
             </a:fld>
             <a:endParaRPr lang="en-US"/>
           </a:p>
@@ -3338,7 +3386,7 @@
           <a:p>
             <a:fld id="{74411A3F-4DB3-47ED-809A-CD27B21BFB64}" type="datetimeFigureOut">
               <a:rPr lang="en-US" smtClean="0"/>
-              <a:t>12/13/2025</a:t>
+              <a:t>12/14/2025</a:t>
             </a:fld>
             <a:endParaRPr lang="en-US"/>
           </a:p>
@@ -3651,7 +3699,7 @@
           <a:p>
             <a:fld id="{74411A3F-4DB3-47ED-809A-CD27B21BFB64}" type="datetimeFigureOut">
               <a:rPr lang="en-US" smtClean="0"/>
-              <a:t>12/13/2025</a:t>
+              <a:t>12/14/2025</a:t>
             </a:fld>
             <a:endParaRPr lang="en-US"/>
           </a:p>
@@ -3991,7 +4039,7 @@
           <a:p>
             <a:fld id="{74411A3F-4DB3-47ED-809A-CD27B21BFB64}" type="datetimeFigureOut">
               <a:rPr lang="en-US" smtClean="0"/>
-              <a:t>12/13/2025</a:t>
+              <a:t>12/14/2025</a:t>
             </a:fld>
             <a:endParaRPr lang="en-US"/>
           </a:p>
@@ -4304,7 +4352,7 @@
           <a:p>
             <a:fld id="{74411A3F-4DB3-47ED-809A-CD27B21BFB64}" type="datetimeFigureOut">
               <a:rPr lang="en-US" smtClean="0"/>
-              <a:t>12/13/2025</a:t>
+              <a:t>12/14/2025</a:t>
             </a:fld>
             <a:endParaRPr lang="en-US"/>
           </a:p>
@@ -4696,7 +4744,7 @@
           <a:p>
             <a:fld id="{74411A3F-4DB3-47ED-809A-CD27B21BFB64}" type="datetimeFigureOut">
               <a:rPr lang="en-US" smtClean="0"/>
-              <a:t>12/13/2025</a:t>
+              <a:t>12/14/2025</a:t>
             </a:fld>
             <a:endParaRPr lang="en-US"/>
           </a:p>
@@ -4864,7 +4912,7 @@
           <a:p>
             <a:fld id="{74411A3F-4DB3-47ED-809A-CD27B21BFB64}" type="datetimeFigureOut">
               <a:rPr lang="en-US" smtClean="0"/>
-              <a:t>12/13/2025</a:t>
+              <a:t>12/14/2025</a:t>
             </a:fld>
             <a:endParaRPr lang="en-US"/>
           </a:p>
@@ -5042,7 +5090,7 @@
           <a:p>
             <a:fld id="{74411A3F-4DB3-47ED-809A-CD27B21BFB64}" type="datetimeFigureOut">
               <a:rPr lang="en-US" smtClean="0"/>
-              <a:t>12/13/2025</a:t>
+              <a:t>12/14/2025</a:t>
             </a:fld>
             <a:endParaRPr lang="en-US"/>
           </a:p>
@@ -5216,7 +5264,7 @@
           <a:p>
             <a:fld id="{74411A3F-4DB3-47ED-809A-CD27B21BFB64}" type="datetimeFigureOut">
               <a:rPr lang="en-US" smtClean="0"/>
-              <a:t>12/13/2025</a:t>
+              <a:t>12/14/2025</a:t>
             </a:fld>
             <a:endParaRPr lang="en-US"/>
           </a:p>
@@ -5462,7 +5510,7 @@
           <a:p>
             <a:fld id="{74411A3F-4DB3-47ED-809A-CD27B21BFB64}" type="datetimeFigureOut">
               <a:rPr lang="en-US" smtClean="0"/>
-              <a:t>12/13/2025</a:t>
+              <a:t>12/14/2025</a:t>
             </a:fld>
             <a:endParaRPr lang="en-US"/>
           </a:p>
@@ -5691,7 +5739,7 @@
           <a:p>
             <a:fld id="{74411A3F-4DB3-47ED-809A-CD27B21BFB64}" type="datetimeFigureOut">
               <a:rPr lang="en-US" smtClean="0"/>
-              <a:t>12/13/2025</a:t>
+              <a:t>12/14/2025</a:t>
             </a:fld>
             <a:endParaRPr lang="en-US"/>
           </a:p>
@@ -6062,7 +6110,7 @@
           <a:p>
             <a:fld id="{74411A3F-4DB3-47ED-809A-CD27B21BFB64}" type="datetimeFigureOut">
               <a:rPr lang="en-US" smtClean="0"/>
-              <a:t>12/13/2025</a:t>
+              <a:t>12/14/2025</a:t>
             </a:fld>
             <a:endParaRPr lang="en-US"/>
           </a:p>
@@ -6184,7 +6232,7 @@
           <a:p>
             <a:fld id="{74411A3F-4DB3-47ED-809A-CD27B21BFB64}" type="datetimeFigureOut">
               <a:rPr lang="en-US" smtClean="0"/>
-              <a:t>12/13/2025</a:t>
+              <a:t>12/14/2025</a:t>
             </a:fld>
             <a:endParaRPr lang="en-US"/>
           </a:p>
@@ -6279,7 +6327,7 @@
           <a:p>
             <a:fld id="{74411A3F-4DB3-47ED-809A-CD27B21BFB64}" type="datetimeFigureOut">
               <a:rPr lang="en-US" smtClean="0"/>
-              <a:t>12/13/2025</a:t>
+              <a:t>12/14/2025</a:t>
             </a:fld>
             <a:endParaRPr lang="en-US"/>
           </a:p>
@@ -6532,7 +6580,7 @@
           <a:p>
             <a:fld id="{74411A3F-4DB3-47ED-809A-CD27B21BFB64}" type="datetimeFigureOut">
               <a:rPr lang="en-US" smtClean="0"/>
-              <a:t>12/13/2025</a:t>
+              <a:t>12/14/2025</a:t>
             </a:fld>
             <a:endParaRPr lang="en-US"/>
           </a:p>
@@ -6793,7 +6841,7 @@
           <a:p>
             <a:fld id="{74411A3F-4DB3-47ED-809A-CD27B21BFB64}" type="datetimeFigureOut">
               <a:rPr lang="en-US" smtClean="0"/>
-              <a:t>12/13/2025</a:t>
+              <a:t>12/14/2025</a:t>
             </a:fld>
             <a:endParaRPr lang="en-US"/>
           </a:p>
@@ -7590,7 +7638,7 @@
           <a:p>
             <a:fld id="{74411A3F-4DB3-47ED-809A-CD27B21BFB64}" type="datetimeFigureOut">
               <a:rPr lang="en-US" smtClean="0"/>
-              <a:t>12/13/2025</a:t>
+              <a:t>12/14/2025</a:t>
             </a:fld>
             <a:endParaRPr lang="en-US"/>
           </a:p>
@@ -8666,7 +8714,7 @@
         </p:nvSpPr>
         <p:spPr>
           <a:xfrm>
-            <a:off x="1413115" y="5166102"/>
+            <a:off x="1413115" y="5747585"/>
             <a:ext cx="9982472" cy="707886"/>
           </a:xfrm>
           <a:prstGeom prst="rect">
@@ -8737,7 +8785,7 @@
         </p:nvSpPr>
         <p:spPr>
           <a:xfrm>
-            <a:off x="1104763" y="6053142"/>
+            <a:off x="1413115" y="5067184"/>
             <a:ext cx="9982472" cy="400110"/>
           </a:xfrm>
           <a:prstGeom prst="rect">
@@ -8854,8 +8902,12 @@
           <a:p>
             <a:pPr algn="ctr"/>
             <a:r>
+              <a:rPr lang="en-US" b="1" dirty="0"/>
+              <a:t>79% of Customers churn </a:t>
+            </a:r>
+            <a:r>
               <a:rPr lang="en-US" dirty="0"/>
-              <a:t>79% of Customers churn after the first month </a:t>
+              <a:t>after the first month </a:t>
             </a:r>
           </a:p>
           <a:p>
@@ -8866,7 +8918,11 @@
             <a:pPr algn="ctr"/>
             <a:r>
               <a:rPr lang="en-US" dirty="0"/>
-              <a:t>Retention generally improves in months 5-7</a:t>
+              <a:t>Retention generally improves in </a:t>
+            </a:r>
+            <a:r>
+              <a:rPr lang="en-US" b="1" dirty="0"/>
+              <a:t>months 5-7</a:t>
             </a:r>
           </a:p>
           <a:p>
@@ -9007,7 +9063,7 @@
         </p:blipFill>
         <p:spPr>
           <a:xfrm>
-            <a:off x="685045" y="2028629"/>
+            <a:off x="685045" y="1228529"/>
             <a:ext cx="10821910" cy="2800741"/>
           </a:xfrm>
           <a:prstGeom prst="rect">
@@ -9080,8 +9136,28 @@
           <a:p>
             <a:pPr algn="ctr"/>
             <a:r>
+              <a:rPr lang="en-US" b="1" dirty="0"/>
+              <a:t>Nearly half </a:t>
+            </a:r>
+            <a:r>
               <a:rPr lang="en-US" dirty="0"/>
-              <a:t>Nearly half of our customers are either “Lost” or “At-Risk High Value,” representing the largest opportunity for retention </a:t>
+              <a:t>of our customers are either </a:t>
+            </a:r>
+            <a:r>
+              <a:rPr lang="en-US" b="1" dirty="0"/>
+              <a:t>“Lost”</a:t>
+            </a:r>
+            <a:r>
+              <a:rPr lang="en-US" dirty="0"/>
+              <a:t> or </a:t>
+            </a:r>
+            <a:r>
+              <a:rPr lang="en-US" b="1" dirty="0"/>
+              <a:t>“At-Risk High Value</a:t>
+            </a:r>
+            <a:r>
+              <a:rPr lang="en-US" dirty="0"/>
+              <a:t>,” representing the largest opportunity for retention </a:t>
             </a:r>
           </a:p>
         </p:txBody>
@@ -9117,7 +9193,15 @@
             <a:pPr algn="ctr"/>
             <a:r>
               <a:rPr lang="en-US" dirty="0"/>
-              <a:t>These two groups make up over 20% of revenue, providing the biggest growth potential</a:t>
+              <a:t>These two groups make up over </a:t>
+            </a:r>
+            <a:r>
+              <a:rPr lang="en-US" b="1" dirty="0"/>
+              <a:t>20% of revenue</a:t>
+            </a:r>
+            <a:r>
+              <a:rPr lang="en-US" dirty="0"/>
+              <a:t>, providing the biggest growth potential</a:t>
             </a:r>
           </a:p>
         </p:txBody>
@@ -9182,15 +9266,169 @@
           <a:p>
             <a:r>
               <a:rPr lang="en-US" sz="2400" dirty="0"/>
-              <a:t>Customers are considered churned after 86 days</a:t>
-            </a:r>
-          </a:p>
-        </p:txBody>
-      </p:sp>
+              <a:t>Customers are considered churned after ~70 days</a:t>
+            </a:r>
+          </a:p>
+        </p:txBody>
+      </p:sp>
+      <p:sp>
+        <p:nvSpPr>
+          <p:cNvPr id="7" name="TextBox 6">
+            <a:extLst>
+              <a:ext uri="{FF2B5EF4-FFF2-40B4-BE49-F238E27FC236}">
+                <a16:creationId xmlns:a16="http://schemas.microsoft.com/office/drawing/2014/main" id="{142FC0C8-9160-88FE-AEBB-0AA357C23B78}"/>
+              </a:ext>
+            </a:extLst>
+          </p:cNvPr>
+          <p:cNvSpPr txBox="1"/>
+          <p:nvPr/>
+        </p:nvSpPr>
+        <p:spPr>
+          <a:xfrm>
+            <a:off x="2366010" y="5812802"/>
+            <a:ext cx="7459980" cy="646331"/>
+          </a:xfrm>
+          <a:prstGeom prst="rect">
+            <a:avLst/>
+          </a:prstGeom>
+          <a:noFill/>
+        </p:spPr>
+        <p:txBody>
+          <a:bodyPr wrap="square" rtlCol="0">
+            <a:spAutoFit/>
+          </a:bodyPr>
+          <a:lstStyle/>
+          <a:p>
+            <a:pPr algn="ctr"/>
+            <a:r>
+              <a:rPr lang="en-US" dirty="0"/>
+              <a:t>Defining the churn window </a:t>
+            </a:r>
+            <a:r>
+              <a:rPr lang="en-US" b="1" dirty="0"/>
+              <a:t>enables retention outreach </a:t>
+            </a:r>
+            <a:r>
+              <a:rPr lang="en-US" dirty="0"/>
+              <a:t>by identifying when intervention is most optimal</a:t>
+            </a:r>
+          </a:p>
+        </p:txBody>
+      </p:sp>
+      <p:pic>
+        <p:nvPicPr>
+          <p:cNvPr id="11" name="Picture 10" descr="A graph of a chart&#10;&#10;AI-generated content may be incorrect.">
+            <a:extLst>
+              <a:ext uri="{FF2B5EF4-FFF2-40B4-BE49-F238E27FC236}">
+                <a16:creationId xmlns:a16="http://schemas.microsoft.com/office/drawing/2014/main" id="{43484889-9244-8A37-1EF2-2AA451491DCB}"/>
+              </a:ext>
+            </a:extLst>
+          </p:cNvPr>
+          <p:cNvPicPr>
+            <a:picLocks noChangeAspect="1"/>
+          </p:cNvPicPr>
+          <p:nvPr/>
+        </p:nvPicPr>
+        <p:blipFill>
+          <a:blip r:embed="rId2"/>
+          <a:stretch>
+            <a:fillRect/>
+          </a:stretch>
+        </p:blipFill>
+        <p:spPr>
+          <a:xfrm>
+            <a:off x="1140542" y="1045198"/>
+            <a:ext cx="9910916" cy="4767604"/>
+          </a:xfrm>
+          <a:prstGeom prst="rect">
+            <a:avLst/>
+          </a:prstGeom>
+        </p:spPr>
+      </p:pic>
     </p:spTree>
     <p:extLst>
       <p:ext uri="{BB962C8B-B14F-4D97-AF65-F5344CB8AC3E}">
         <p14:creationId xmlns:p14="http://schemas.microsoft.com/office/powerpoint/2010/main" val="3083110177"/>
+      </p:ext>
+    </p:extLst>
+  </p:cSld>
+  <p:clrMapOvr>
+    <a:masterClrMapping/>
+  </p:clrMapOvr>
+</p:sld>
+</file>
+
+<file path=ppt/slides/slide7.xml><?xml version="1.0" encoding="utf-8"?>
+<p:sld xmlns:a="http://schemas.openxmlformats.org/drawingml/2006/main" xmlns:r="http://schemas.openxmlformats.org/officeDocument/2006/relationships" xmlns:p="http://schemas.openxmlformats.org/presentationml/2006/main">
+  <p:cSld>
+    <p:spTree>
+      <p:nvGrpSpPr>
+        <p:cNvPr id="1" name=""/>
+        <p:cNvGrpSpPr/>
+        <p:nvPr/>
+      </p:nvGrpSpPr>
+      <p:grpSpPr>
+        <a:xfrm>
+          <a:off x="0" y="0"/>
+          <a:ext cx="0" cy="0"/>
+          <a:chOff x="0" y="0"/>
+          <a:chExt cx="0" cy="0"/>
+        </a:xfrm>
+      </p:grpSpPr>
+      <p:sp>
+        <p:nvSpPr>
+          <p:cNvPr id="2" name="Title 1">
+            <a:extLst>
+              <a:ext uri="{FF2B5EF4-FFF2-40B4-BE49-F238E27FC236}">
+                <a16:creationId xmlns:a16="http://schemas.microsoft.com/office/drawing/2014/main" id="{C25EEB97-A683-1B60-28CE-C085CD9548B0}"/>
+              </a:ext>
+            </a:extLst>
+          </p:cNvPr>
+          <p:cNvSpPr>
+            <a:spLocks noGrp="1"/>
+          </p:cNvSpPr>
+          <p:nvPr>
+            <p:ph type="title"/>
+          </p:nvPr>
+        </p:nvSpPr>
+        <p:spPr/>
+        <p:txBody>
+          <a:bodyPr/>
+          <a:lstStyle/>
+          <a:p>
+            <a:endParaRPr lang="en-US"/>
+          </a:p>
+        </p:txBody>
+      </p:sp>
+      <p:sp>
+        <p:nvSpPr>
+          <p:cNvPr id="3" name="Content Placeholder 2">
+            <a:extLst>
+              <a:ext uri="{FF2B5EF4-FFF2-40B4-BE49-F238E27FC236}">
+                <a16:creationId xmlns:a16="http://schemas.microsoft.com/office/drawing/2014/main" id="{08F07BE0-530E-DBC5-0506-8821B3863CCE}"/>
+              </a:ext>
+            </a:extLst>
+          </p:cNvPr>
+          <p:cNvSpPr>
+            <a:spLocks noGrp="1"/>
+          </p:cNvSpPr>
+          <p:nvPr>
+            <p:ph idx="1"/>
+          </p:nvPr>
+        </p:nvSpPr>
+        <p:spPr/>
+        <p:txBody>
+          <a:bodyPr/>
+          <a:lstStyle/>
+          <a:p>
+            <a:endParaRPr lang="en-US"/>
+          </a:p>
+        </p:txBody>
+      </p:sp>
+    </p:spTree>
+    <p:extLst>
+      <p:ext uri="{BB962C8B-B14F-4D97-AF65-F5344CB8AC3E}">
+        <p14:creationId xmlns:p14="http://schemas.microsoft.com/office/powerpoint/2010/main" val="3533779975"/>
       </p:ext>
     </p:extLst>
   </p:cSld>

</xml_diff>